<commit_message>
Presentación: antecedentes detallados y mismo orden del informe
- Antecedentes como en el Word: estudios tomados, cada estudio con
  objetivos, justificación, diseño metodológico, resultados y aporte;
  estado actual del conocimiento al final
- Marcos en el orden del Word: demográfico y geográfico, histórico
  (nuevo), legal e institucional (nuevo)

Co-Authored-By: Claude Opus 5.5 <noreply@anthropic.com>
Claude-Session: https://claude.ai/code/session_018bHYprMg3dLh9Z1z1BuPi9
</commit_message>
<xml_diff>
--- a/Luna_de_Cristal_Presentacion_SENA.pptx
+++ b/Luna_de_Cristal_Presentacion_SENA.pptx
@@ -12,6 +12,12 @@
     <p:sldId id="257" r:id="rId102"/>
     <p:sldId id="258" r:id="rId103"/>
     <p:sldId id="259" r:id="rId104"/>
+    <p:sldId id="286" r:id="rId131"/>
+    <p:sldId id="285" r:id="rId130"/>
+    <p:sldId id="284" r:id="rId129"/>
+    <p:sldId id="283" r:id="rId128"/>
+    <p:sldId id="282" r:id="rId127"/>
+    <p:sldId id="281" r:id="rId126"/>
     <p:sldId id="260" r:id="rId105"/>
     <p:sldId id="261" r:id="rId106"/>
     <p:sldId id="262" r:id="rId107"/>
@@ -24,8 +30,10 @@
     <p:sldId id="269" r:id="rId114"/>
     <p:sldId id="270" r:id="rId115"/>
     <p:sldId id="271" r:id="rId116"/>
+    <p:sldId id="273" r:id="rId118"/>
+    <p:sldId id="287" r:id="rId132"/>
     <p:sldId id="272" r:id="rId117"/>
-    <p:sldId id="273" r:id="rId118"/>
+    <p:sldId id="288" r:id="rId133"/>
     <p:sldId id="274" r:id="rId119"/>
     <p:sldId id="275" r:id="rId120"/>
     <p:sldId id="276" r:id="rId121"/>
@@ -14468,7 +14476,7 @@
                 <a:cs typeface="Work Sans"/>
                 <a:sym typeface="Work Sans"/>
               </a:rPr>
-              <a:t>Marco demográfico, geográfico e institucional</a:t>
+              <a:t>Marco demográfico y geográfico</a:t>
             </a:r>
           </a:p>
         </p:txBody>
@@ -14498,20 +14506,25 @@
           </a:bodyPr>
           <a:lstStyle/>
           <a:p>
-            <a:pPr indent="0" lvl="0" marL="0" marR="0" rtl="0" algn="l">
-              <a:lnSpc>
-                <a:spcPct val="110000"/>
-              </a:lnSpc>
-              <a:spcBef>
-                <a:spcPts val="0"/>
-              </a:spcBef>
-              <a:spcAft>
-                <a:spcPts val="600"/>
-              </a:spcAft>
-              <a:buNone/>
+            <a:pPr indent="-228600" lvl="0" marL="274320" marR="0" rtl="0" algn="l">
+              <a:lnSpc>
+                <a:spcPct val="100000"/>
+              </a:lnSpc>
+              <a:spcBef>
+                <a:spcPts val="0"/>
+              </a:spcBef>
+              <a:spcAft>
+                <a:spcPts val="400"/>
+              </a:spcAft>
+              <a:buClr>
+                <a:srgbClr val="39A935"/>
+              </a:buClr>
+              <a:buSzPct val="90000"/>
+              <a:buFont typeface="Arial"/>
+              <a:buChar char="•"/>
             </a:pPr>
             <a:r>
-              <a:rPr lang="es-CO" sz="1800">
+              <a:rPr lang="es-CO" sz="1500" b="1">
                 <a:solidFill>
                   <a:srgbClr val="262626"/>
                 </a:solidFill>
@@ -14520,24 +14533,10 @@
                 <a:cs typeface="Work Sans Light"/>
                 <a:sym typeface="Work Sans Light"/>
               </a:rPr>
-              <a:t>Yopal tiene 192.468 habitantes (50,6 % mujeres) y concentra el 41,2 % de Casanare.</a:t>
+              <a:t>Demográfico: </a:t>
             </a:r>
-          </a:p>
-          <a:p>
-            <a:pPr indent="0" lvl="0" marL="0" marR="0" rtl="0" algn="l">
-              <a:lnSpc>
-                <a:spcPct val="110000"/>
-              </a:lnSpc>
-              <a:spcBef>
-                <a:spcPts val="0"/>
-              </a:spcBef>
-              <a:spcAft>
-                <a:spcPts val="600"/>
-              </a:spcAft>
-              <a:buNone/>
-            </a:pPr>
             <a:r>
-              <a:rPr lang="es-CO" sz="1800">
+              <a:rPr lang="es-CO" sz="1500">
                 <a:solidFill>
                   <a:srgbClr val="262626"/>
                 </a:solidFill>
@@ -14546,24 +14545,29 @@
                 <a:cs typeface="Work Sans Light"/>
                 <a:sym typeface="Work Sans Light"/>
               </a:rPr>
-              <a:t>El comercio es la principal actividad: 12.001 empresas, 94 % microempresas. La tienda está en la Carrera 19 #23-57, centro de Yopal.</a:t>
+              <a:t>Yopal tiene 192.468 habitantes (DANE, 2024), el 50,6 % mujeres, y concentra el 41,2 % de la población de Casanare.</a:t>
             </a:r>
           </a:p>
           <a:p>
-            <a:pPr indent="0" lvl="0" marL="0" marR="0" rtl="0" algn="l">
-              <a:lnSpc>
-                <a:spcPct val="110000"/>
-              </a:lnSpc>
-              <a:spcBef>
-                <a:spcPts val="0"/>
-              </a:spcBef>
-              <a:spcAft>
-                <a:spcPts val="600"/>
-              </a:spcAft>
-              <a:buNone/>
+            <a:pPr indent="-228600" lvl="0" marL="274320" marR="0" rtl="0" algn="l">
+              <a:lnSpc>
+                <a:spcPct val="100000"/>
+              </a:lnSpc>
+              <a:spcBef>
+                <a:spcPts val="0"/>
+              </a:spcBef>
+              <a:spcAft>
+                <a:spcPts val="400"/>
+              </a:spcAft>
+              <a:buClr>
+                <a:srgbClr val="39A935"/>
+              </a:buClr>
+              <a:buSzPct val="90000"/>
+              <a:buFont typeface="Arial"/>
+              <a:buChar char="•"/>
             </a:pPr>
             <a:r>
-              <a:rPr lang="es-CO" sz="1800">
+              <a:rPr lang="es-CO" sz="1500" b="1">
                 <a:solidFill>
                   <a:srgbClr val="262626"/>
                 </a:solidFill>
@@ -14572,7 +14576,105 @@
                 <a:cs typeface="Work Sans Light"/>
                 <a:sym typeface="Work Sans Light"/>
               </a:rPr>
-              <a:t>El proyecto se respalda en el SENA, programa de Gestión Administrativa e Innovación.</a:t>
+              <a:t>Mercado objetivo: </a:t>
+            </a:r>
+            <a:r>
+              <a:rPr lang="es-CO" sz="1500">
+                <a:solidFill>
+                  <a:srgbClr val="262626"/>
+                </a:solidFill>
+                <a:latin typeface="Work Sans Light"/>
+                <a:ea typeface="Work Sans Light"/>
+                <a:cs typeface="Work Sans Light"/>
+                <a:sym typeface="Work Sans Light"/>
+              </a:rPr>
+              <a:t>mujeres de 16 a 60 años de Yopal y municipios aledaños, estratos 1 a 3; la tienda atiende unas siete clientas al día.</a:t>
+            </a:r>
+          </a:p>
+          <a:p>
+            <a:pPr indent="-228600" lvl="0" marL="274320" marR="0" rtl="0" algn="l">
+              <a:lnSpc>
+                <a:spcPct val="100000"/>
+              </a:lnSpc>
+              <a:spcBef>
+                <a:spcPts val="0"/>
+              </a:spcBef>
+              <a:spcAft>
+                <a:spcPts val="400"/>
+              </a:spcAft>
+              <a:buClr>
+                <a:srgbClr val="39A935"/>
+              </a:buClr>
+              <a:buSzPct val="90000"/>
+              <a:buFont typeface="Arial"/>
+              <a:buChar char="•"/>
+            </a:pPr>
+            <a:r>
+              <a:rPr lang="es-CO" sz="1500" b="1">
+                <a:solidFill>
+                  <a:srgbClr val="262626"/>
+                </a:solidFill>
+                <a:latin typeface="Work Sans Light"/>
+                <a:ea typeface="Work Sans Light"/>
+                <a:cs typeface="Work Sans Light"/>
+                <a:sym typeface="Work Sans Light"/>
+              </a:rPr>
+              <a:t>Empresarial: </a:t>
+            </a:r>
+            <a:r>
+              <a:rPr lang="es-CO" sz="1500">
+                <a:solidFill>
+                  <a:srgbClr val="262626"/>
+                </a:solidFill>
+                <a:latin typeface="Work Sans Light"/>
+                <a:ea typeface="Work Sans Light"/>
+                <a:cs typeface="Work Sans Light"/>
+                <a:sym typeface="Work Sans Light"/>
+              </a:rPr>
+              <a:t>el comercio es la principal actividad de Casanare (12.001 empresas); el 94 % son microempresas.</a:t>
+            </a:r>
+          </a:p>
+          <a:p>
+            <a:pPr indent="-228600" lvl="0" marL="274320" marR="0" rtl="0" algn="l">
+              <a:lnSpc>
+                <a:spcPct val="100000"/>
+              </a:lnSpc>
+              <a:spcBef>
+                <a:spcPts val="0"/>
+              </a:spcBef>
+              <a:spcAft>
+                <a:spcPts val="0"/>
+              </a:spcAft>
+              <a:buClr>
+                <a:srgbClr val="39A935"/>
+              </a:buClr>
+              <a:buSzPct val="90000"/>
+              <a:buFont typeface="Arial"/>
+              <a:buChar char="•"/>
+            </a:pPr>
+            <a:r>
+              <a:rPr lang="es-CO" sz="1500" b="1">
+                <a:solidFill>
+                  <a:srgbClr val="262626"/>
+                </a:solidFill>
+                <a:latin typeface="Work Sans Light"/>
+                <a:ea typeface="Work Sans Light"/>
+                <a:cs typeface="Work Sans Light"/>
+                <a:sym typeface="Work Sans Light"/>
+              </a:rPr>
+              <a:t>Geográfico: </a:t>
+            </a:r>
+            <a:r>
+              <a:rPr lang="es-CO" sz="1500">
+                <a:solidFill>
+                  <a:srgbClr val="262626"/>
+                </a:solidFill>
+                <a:latin typeface="Work Sans Light"/>
+                <a:ea typeface="Work Sans Light"/>
+                <a:cs typeface="Work Sans Light"/>
+                <a:sym typeface="Work Sans Light"/>
+              </a:rPr>
+              <a:t>Yopal es la capital de Casanare, en la Orinoquía. La tienda está en la Carrera 19 #23-57, centro de la ciudad.</a:t>
             </a:r>
           </a:p>
         </p:txBody>
@@ -15923,6 +16025,1759 @@
 </p:sld>
 </file>
 
+<file path=ppt/slides/slide26.xml><?xml version="1.0" encoding="utf-8"?>
+<p:sld xmlns:a="http://schemas.openxmlformats.org/drawingml/2006/main" xmlns:r="http://schemas.openxmlformats.org/officeDocument/2006/relationships" xmlns:p="http://schemas.openxmlformats.org/presentationml/2006/main">
+  <p:cSld>
+    <p:bg>
+      <p:bgPr>
+        <a:blipFill>
+          <a:blip r:embed="rId3">
+            <a:alphaModFix/>
+          </a:blip>
+          <a:stretch>
+            <a:fillRect/>
+          </a:stretch>
+        </a:blipFill>
+      </p:bgPr>
+    </p:bg>
+    <p:spTree>
+      <p:nvGrpSpPr>
+        <p:cNvPr id="1" name=""/>
+        <p:cNvGrpSpPr/>
+        <p:nvPr/>
+      </p:nvGrpSpPr>
+      <p:grpSpPr>
+        <a:xfrm>
+          <a:off x="0" y="0"/>
+          <a:ext cx="0" cy="0"/>
+          <a:chOff x="0" y="0"/>
+          <a:chExt cx="0" cy="0"/>
+        </a:xfrm>
+      </p:grpSpPr>
+      <p:sp>
+        <p:nvSpPr>
+          <p:cNvPr id="158" name="encabezado"/>
+          <p:cNvSpPr txBox="1"/>
+          <p:nvPr/>
+        </p:nvSpPr>
+        <p:spPr>
+          <a:xfrm>
+            <a:off x="694944" y="868680"/>
+            <a:ext cx="10789920" cy="822960"/>
+          </a:xfrm>
+          <a:prstGeom prst="rect">
+            <a:avLst/>
+          </a:prstGeom>
+          <a:noFill/>
+          <a:ln>
+            <a:noFill/>
+          </a:ln>
+        </p:spPr>
+        <p:txBody>
+          <a:bodyPr anchorCtr="0" anchor="t" bIns="45700" lIns="91425" spcFirstLastPara="1" rIns="91425" wrap="square" tIns="45700">
+            <a:noAutofit/>
+          </a:bodyPr>
+          <a:lstStyle/>
+          <a:p>
+            <a:pPr indent="0" lvl="0" marL="0" marR="0" rtl="0" algn="l">
+              <a:lnSpc>
+                <a:spcPct val="95000"/>
+              </a:lnSpc>
+              <a:spcBef>
+                <a:spcPts val="0"/>
+              </a:spcBef>
+              <a:spcAft>
+                <a:spcPts val="0"/>
+              </a:spcAft>
+              <a:buNone/>
+            </a:pPr>
+            <a:r>
+              <a:rPr b="1" lang="es-CO" sz="3200">
+                <a:solidFill>
+                  <a:srgbClr val="4D4D4C"/>
+                </a:solidFill>
+                <a:latin typeface="Work Sans"/>
+                <a:ea typeface="Work Sans"/>
+                <a:cs typeface="Work Sans"/>
+                <a:sym typeface="Work Sans"/>
+              </a:rPr>
+              <a:t>Estado actual del conocimiento y aportes</a:t>
+            </a:r>
+          </a:p>
+        </p:txBody>
+      </p:sp>
+      <p:sp>
+        <p:nvSpPr>
+          <p:cNvPr id="159" name="cuerpo"/>
+          <p:cNvSpPr txBox="1"/>
+          <p:nvPr/>
+        </p:nvSpPr>
+        <p:spPr>
+          <a:xfrm>
+            <a:off x="694944" y="1874520"/>
+            <a:ext cx="6309360" cy="4297680"/>
+          </a:xfrm>
+          <a:prstGeom prst="rect">
+            <a:avLst/>
+          </a:prstGeom>
+          <a:noFill/>
+          <a:ln>
+            <a:noFill/>
+          </a:ln>
+        </p:spPr>
+        <p:txBody>
+          <a:bodyPr anchorCtr="0" anchor="t" bIns="45700" lIns="91425" spcFirstLastPara="1" rIns="91425" wrap="square" tIns="45700">
+            <a:normAutofit/>
+          </a:bodyPr>
+          <a:lstStyle/>
+          <a:p>
+            <a:pPr indent="-228600" lvl="0" marL="274320" marR="0" rtl="0" algn="l">
+              <a:lnSpc>
+                <a:spcPct val="100000"/>
+              </a:lnSpc>
+              <a:spcBef>
+                <a:spcPts val="0"/>
+              </a:spcBef>
+              <a:spcAft>
+                <a:spcPts val="600"/>
+              </a:spcAft>
+              <a:buClr>
+                <a:srgbClr val="39A935"/>
+              </a:buClr>
+              <a:buSzPct val="90000"/>
+              <a:buFont typeface="Arial"/>
+              <a:buChar char="•"/>
+            </a:pPr>
+            <a:r>
+              <a:rPr lang="es-CO" sz="1500" b="1">
+                <a:solidFill>
+                  <a:srgbClr val="262626"/>
+                </a:solidFill>
+                <a:latin typeface="Work Sans Light"/>
+                <a:ea typeface="Work Sans Light"/>
+                <a:cs typeface="Work Sans Light"/>
+                <a:sym typeface="Work Sans Light"/>
+              </a:rPr>
+              <a:t>Estado actual: </a:t>
+            </a:r>
+            <a:r>
+              <a:rPr lang="es-CO" sz="1500">
+                <a:solidFill>
+                  <a:srgbClr val="262626"/>
+                </a:solidFill>
+                <a:latin typeface="Work Sans Light"/>
+                <a:ea typeface="Work Sans Light"/>
+                <a:cs typeface="Work Sans Light"/>
+                <a:sym typeface="Work Sans Light"/>
+              </a:rPr>
+              <a:t>el comercio de moda en Latinoamérica se ha desplazado hacia los canales digitales y las redes sociales; las microempresas que integran estas herramientas mejoran su posicionamiento y sus ventas (Cervera Wong &amp; Bonifacio Salazar, 2024; Luna Morelo et al., 2024).</a:t>
+            </a:r>
+          </a:p>
+          <a:p>
+            <a:pPr indent="0" lvl="0" marL="0" marR="0" rtl="0" algn="l">
+              <a:lnSpc>
+                <a:spcPct val="100000"/>
+              </a:lnSpc>
+              <a:spcBef>
+                <a:spcPts val="0"/>
+              </a:spcBef>
+              <a:spcAft>
+                <a:spcPts val="200"/>
+              </a:spcAft>
+              <a:buNone/>
+            </a:pPr>
+            <a:r>
+              <a:rPr lang="es-CO" sz="1500" b="1">
+                <a:solidFill>
+                  <a:srgbClr val="262626"/>
+                </a:solidFill>
+                <a:latin typeface="Work Sans Light"/>
+                <a:ea typeface="Work Sans Light"/>
+                <a:cs typeface="Work Sans Light"/>
+                <a:sym typeface="Work Sans Light"/>
+              </a:rPr>
+              <a:t>Aportes a Luna de Cristal:</a:t>
+            </a:r>
+          </a:p>
+          <a:p>
+            <a:pPr indent="-228600" lvl="0" marL="274320" marR="0" rtl="0" algn="l">
+              <a:lnSpc>
+                <a:spcPct val="100000"/>
+              </a:lnSpc>
+              <a:spcBef>
+                <a:spcPts val="0"/>
+              </a:spcBef>
+              <a:spcAft>
+                <a:spcPts val="200"/>
+              </a:spcAft>
+              <a:buClr>
+                <a:srgbClr val="39A935"/>
+              </a:buClr>
+              <a:buSzPct val="90000"/>
+              <a:buFont typeface="Arial"/>
+              <a:buChar char="•"/>
+            </a:pPr>
+            <a:r>
+              <a:rPr lang="es-CO" sz="1500" b="1">
+                <a:solidFill>
+                  <a:srgbClr val="262626"/>
+                </a:solidFill>
+                <a:latin typeface="Work Sans Light"/>
+                <a:ea typeface="Work Sans Light"/>
+                <a:cs typeface="Work Sans Light"/>
+                <a:sym typeface="Work Sans Light"/>
+              </a:rPr>
+              <a:t>Gallego y Durán: </a:t>
+            </a:r>
+            <a:r>
+              <a:rPr lang="es-CO" sz="1500">
+                <a:solidFill>
+                  <a:srgbClr val="262626"/>
+                </a:solidFill>
+                <a:latin typeface="Work Sans Light"/>
+                <a:ea typeface="Work Sans Light"/>
+                <a:cs typeface="Work Sans Light"/>
+                <a:sym typeface="Work Sans Light"/>
+              </a:rPr>
+              <a:t>portafolio visual, fácil e integrado con ventas, inventario y redes.</a:t>
+            </a:r>
+          </a:p>
+          <a:p>
+            <a:pPr indent="-228600" lvl="0" marL="274320" marR="0" rtl="0" algn="l">
+              <a:lnSpc>
+                <a:spcPct val="100000"/>
+              </a:lnSpc>
+              <a:spcBef>
+                <a:spcPts val="0"/>
+              </a:spcBef>
+              <a:spcAft>
+                <a:spcPts val="200"/>
+              </a:spcAft>
+              <a:buClr>
+                <a:srgbClr val="39A935"/>
+              </a:buClr>
+              <a:buSzPct val="90000"/>
+              <a:buFont typeface="Arial"/>
+              <a:buChar char="•"/>
+            </a:pPr>
+            <a:r>
+              <a:rPr lang="es-CO" sz="1500" b="1">
+                <a:solidFill>
+                  <a:srgbClr val="262626"/>
+                </a:solidFill>
+                <a:latin typeface="Work Sans Light"/>
+                <a:ea typeface="Work Sans Light"/>
+                <a:cs typeface="Work Sans Light"/>
+                <a:sym typeface="Work Sans Light"/>
+              </a:rPr>
+              <a:t>Fuentes y Mejía: </a:t>
+            </a:r>
+            <a:r>
+              <a:rPr lang="es-CO" sz="1500">
+                <a:solidFill>
+                  <a:srgbClr val="262626"/>
+                </a:solidFill>
+                <a:latin typeface="Work Sans Light"/>
+                <a:ea typeface="Work Sans Light"/>
+                <a:cs typeface="Work Sans Light"/>
+                <a:sym typeface="Work Sans Light"/>
+              </a:rPr>
+              <a:t>conocer a las clientas y el mercado antes de decidir.</a:t>
+            </a:r>
+          </a:p>
+          <a:p>
+            <a:pPr indent="-228600" lvl="0" marL="274320" marR="0" rtl="0" algn="l">
+              <a:lnSpc>
+                <a:spcPct val="100000"/>
+              </a:lnSpc>
+              <a:spcBef>
+                <a:spcPts val="0"/>
+              </a:spcBef>
+              <a:spcAft>
+                <a:spcPts val="0"/>
+              </a:spcAft>
+              <a:buClr>
+                <a:srgbClr val="39A935"/>
+              </a:buClr>
+              <a:buSzPct val="90000"/>
+              <a:buFont typeface="Arial"/>
+              <a:buChar char="•"/>
+            </a:pPr>
+            <a:r>
+              <a:rPr lang="es-CO" sz="1500" b="1">
+                <a:solidFill>
+                  <a:srgbClr val="262626"/>
+                </a:solidFill>
+                <a:latin typeface="Work Sans Light"/>
+                <a:ea typeface="Work Sans Light"/>
+                <a:cs typeface="Work Sans Light"/>
+                <a:sym typeface="Work Sans Light"/>
+              </a:rPr>
+              <a:t>Lago Padilla et al.: </a:t>
+            </a:r>
+            <a:r>
+              <a:rPr lang="es-CO" sz="1500">
+                <a:solidFill>
+                  <a:srgbClr val="262626"/>
+                </a:solidFill>
+                <a:latin typeface="Work Sans Light"/>
+                <a:ea typeface="Work Sans Light"/>
+                <a:cs typeface="Work Sans Light"/>
+                <a:sym typeface="Work Sans Light"/>
+              </a:rPr>
+              <a:t>integrar demanda, operaciones y viabilidad (CANVAS).</a:t>
+            </a:r>
+          </a:p>
+        </p:txBody>
+      </p:sp>
+      <p:pic>
+        <p:nvPicPr>
+          <p:cNvPr id="200" name="imagen"/>
+          <p:cNvPicPr/>
+          <p:nvPr/>
+        </p:nvPicPr>
+        <p:blipFill>
+          <a:blip r:embed="rId5">
+            <a:alphaModFix/>
+          </a:blip>
+          <a:stretch>
+            <a:fillRect/>
+          </a:stretch>
+        </p:blipFill>
+        <p:spPr>
+          <a:xfrm>
+            <a:off x="7269480" y="1920240"/>
+            <a:ext cx="4114800" cy="3090672"/>
+          </a:xfrm>
+          <a:prstGeom prst="roundRect">
+            <a:avLst>
+              <a:gd name="adj" fmla="val 5000"/>
+            </a:avLst>
+          </a:prstGeom>
+          <a:ln w="12700">
+            <a:solidFill>
+              <a:srgbClr val="FFFFFF"/>
+            </a:solidFill>
+          </a:ln>
+          <a:effectLst>
+            <a:outerShdw blurRad="50000" dist="25000" dir="5400000" rotWithShape="0">
+              <a:srgbClr val="000000">
+                <a:alpha val="25000"/>
+              </a:srgbClr>
+            </a:outerShdw>
+          </a:effectLst>
+        </p:spPr>
+      </p:pic>
+    </p:spTree>
+  </p:cSld>
+  <p:clrMapOvr>
+    <a:masterClrMapping/>
+  </p:clrMapOvr>
+</p:sld>
+</file>
+
+<file path=ppt/slides/slide27.xml><?xml version="1.0" encoding="utf-8"?>
+<p:sld xmlns:a="http://schemas.openxmlformats.org/drawingml/2006/main" xmlns:r="http://schemas.openxmlformats.org/officeDocument/2006/relationships" xmlns:p="http://schemas.openxmlformats.org/presentationml/2006/main">
+  <p:cSld>
+    <p:bg>
+      <p:bgPr>
+        <a:blipFill>
+          <a:blip r:embed="rId3">
+            <a:alphaModFix/>
+          </a:blip>
+          <a:stretch>
+            <a:fillRect/>
+          </a:stretch>
+        </a:blipFill>
+      </p:bgPr>
+    </p:bg>
+    <p:spTree>
+      <p:nvGrpSpPr>
+        <p:cNvPr id="1" name=""/>
+        <p:cNvGrpSpPr/>
+        <p:nvPr/>
+      </p:nvGrpSpPr>
+      <p:grpSpPr>
+        <a:xfrm>
+          <a:off x="0" y="0"/>
+          <a:ext cx="0" cy="0"/>
+          <a:chOff x="0" y="0"/>
+          <a:chExt cx="0" cy="0"/>
+        </a:xfrm>
+      </p:grpSpPr>
+      <p:sp>
+        <p:nvSpPr>
+          <p:cNvPr id="158" name="encabezado"/>
+          <p:cNvSpPr txBox="1"/>
+          <p:nvPr/>
+        </p:nvSpPr>
+        <p:spPr>
+          <a:xfrm>
+            <a:off x="694944" y="868680"/>
+            <a:ext cx="10789920" cy="822960"/>
+          </a:xfrm>
+          <a:prstGeom prst="rect">
+            <a:avLst/>
+          </a:prstGeom>
+          <a:noFill/>
+          <a:ln>
+            <a:noFill/>
+          </a:ln>
+        </p:spPr>
+        <p:txBody>
+          <a:bodyPr anchorCtr="0" anchor="t" bIns="45700" lIns="91425" spcFirstLastPara="1" rIns="91425" wrap="square" tIns="45700">
+            <a:noAutofit/>
+          </a:bodyPr>
+          <a:lstStyle/>
+          <a:p>
+            <a:pPr indent="0" lvl="0" marL="0" marR="0" rtl="0" algn="l">
+              <a:lnSpc>
+                <a:spcPct val="95000"/>
+              </a:lnSpc>
+              <a:spcBef>
+                <a:spcPts val="0"/>
+              </a:spcBef>
+              <a:spcAft>
+                <a:spcPts val="0"/>
+              </a:spcAft>
+              <a:buNone/>
+            </a:pPr>
+            <a:r>
+              <a:rPr b="1" lang="es-CO" sz="3200">
+                <a:solidFill>
+                  <a:srgbClr val="4D4D4C"/>
+                </a:solidFill>
+                <a:latin typeface="Work Sans"/>
+                <a:ea typeface="Work Sans"/>
+                <a:cs typeface="Work Sans"/>
+                <a:sym typeface="Work Sans"/>
+              </a:rPr>
+              <a:t>Antecedente 3: diseño metodológico y resultados</a:t>
+            </a:r>
+          </a:p>
+        </p:txBody>
+      </p:sp>
+      <p:sp>
+        <p:nvSpPr>
+          <p:cNvPr id="159" name="cuerpo"/>
+          <p:cNvSpPr txBox="1"/>
+          <p:nvPr/>
+        </p:nvSpPr>
+        <p:spPr>
+          <a:xfrm>
+            <a:off x="694944" y="1874520"/>
+            <a:ext cx="6309360" cy="4297680"/>
+          </a:xfrm>
+          <a:prstGeom prst="rect">
+            <a:avLst/>
+          </a:prstGeom>
+          <a:noFill/>
+          <a:ln>
+            <a:noFill/>
+          </a:ln>
+        </p:spPr>
+        <p:txBody>
+          <a:bodyPr anchorCtr="0" anchor="t" bIns="45700" lIns="91425" spcFirstLastPara="1" rIns="91425" wrap="square" tIns="45700">
+            <a:normAutofit/>
+          </a:bodyPr>
+          <a:lstStyle/>
+          <a:p>
+            <a:pPr indent="-228600" lvl="0" marL="274320" marR="0" rtl="0" algn="l">
+              <a:lnSpc>
+                <a:spcPct val="100000"/>
+              </a:lnSpc>
+              <a:spcBef>
+                <a:spcPts val="0"/>
+              </a:spcBef>
+              <a:spcAft>
+                <a:spcPts val="400"/>
+              </a:spcAft>
+              <a:buClr>
+                <a:srgbClr val="39A935"/>
+              </a:buClr>
+              <a:buSzPct val="90000"/>
+              <a:buFont typeface="Arial"/>
+              <a:buChar char="•"/>
+            </a:pPr>
+            <a:r>
+              <a:rPr lang="es-CO" sz="1500" b="1">
+                <a:solidFill>
+                  <a:srgbClr val="262626"/>
+                </a:solidFill>
+                <a:latin typeface="Work Sans Light"/>
+                <a:ea typeface="Work Sans Light"/>
+                <a:cs typeface="Work Sans Light"/>
+                <a:sym typeface="Work Sans Light"/>
+              </a:rPr>
+              <a:t>Enfoque: </a:t>
+            </a:r>
+            <a:r>
+              <a:rPr lang="es-CO" sz="1500">
+                <a:solidFill>
+                  <a:srgbClr val="262626"/>
+                </a:solidFill>
+                <a:latin typeface="Work Sans Light"/>
+                <a:ea typeface="Work Sans Light"/>
+                <a:cs typeface="Work Sans Light"/>
+                <a:sym typeface="Work Sans Light"/>
+              </a:rPr>
+              <a:t>cuantitativo; encuestas para determinar el potencial de la demanda femenina.</a:t>
+            </a:r>
+          </a:p>
+          <a:p>
+            <a:pPr indent="-228600" lvl="0" marL="274320" marR="0" rtl="0" algn="l">
+              <a:lnSpc>
+                <a:spcPct val="100000"/>
+              </a:lnSpc>
+              <a:spcBef>
+                <a:spcPts val="0"/>
+              </a:spcBef>
+              <a:spcAft>
+                <a:spcPts val="400"/>
+              </a:spcAft>
+              <a:buClr>
+                <a:srgbClr val="39A935"/>
+              </a:buClr>
+              <a:buSzPct val="90000"/>
+              <a:buFont typeface="Arial"/>
+              <a:buChar char="•"/>
+            </a:pPr>
+            <a:r>
+              <a:rPr lang="es-CO" sz="1500" b="1">
+                <a:solidFill>
+                  <a:srgbClr val="262626"/>
+                </a:solidFill>
+                <a:latin typeface="Work Sans Light"/>
+                <a:ea typeface="Work Sans Light"/>
+                <a:cs typeface="Work Sans Light"/>
+                <a:sym typeface="Work Sans Light"/>
+              </a:rPr>
+              <a:t>Tipo y alcance: </a:t>
+            </a:r>
+            <a:r>
+              <a:rPr lang="es-CO" sz="1500">
+                <a:solidFill>
+                  <a:srgbClr val="262626"/>
+                </a:solidFill>
+                <a:latin typeface="Work Sans Light"/>
+                <a:ea typeface="Work Sans Light"/>
+                <a:cs typeface="Work Sans Light"/>
+                <a:sym typeface="Work Sans Light"/>
+              </a:rPr>
+              <a:t>descriptivo, con propósito aplicado.</a:t>
+            </a:r>
+          </a:p>
+          <a:p>
+            <a:pPr indent="-228600" lvl="0" marL="274320" marR="0" rtl="0" algn="l">
+              <a:lnSpc>
+                <a:spcPct val="100000"/>
+              </a:lnSpc>
+              <a:spcBef>
+                <a:spcPts val="0"/>
+              </a:spcBef>
+              <a:spcAft>
+                <a:spcPts val="400"/>
+              </a:spcAft>
+              <a:buClr>
+                <a:srgbClr val="39A935"/>
+              </a:buClr>
+              <a:buSzPct val="90000"/>
+              <a:buFont typeface="Arial"/>
+              <a:buChar char="•"/>
+            </a:pPr>
+            <a:r>
+              <a:rPr lang="es-CO" sz="1500" b="1">
+                <a:solidFill>
+                  <a:srgbClr val="262626"/>
+                </a:solidFill>
+                <a:latin typeface="Work Sans Light"/>
+                <a:ea typeface="Work Sans Light"/>
+                <a:cs typeface="Work Sans Light"/>
+                <a:sym typeface="Work Sans Light"/>
+              </a:rPr>
+              <a:t>Diseño: </a:t>
+            </a:r>
+            <a:r>
+              <a:rPr lang="es-CO" sz="1500">
+                <a:solidFill>
+                  <a:srgbClr val="262626"/>
+                </a:solidFill>
+                <a:latin typeface="Work Sans Light"/>
+                <a:ea typeface="Work Sans Light"/>
+                <a:cs typeface="Work Sans Light"/>
+                <a:sym typeface="Work Sans Light"/>
+              </a:rPr>
+              <a:t>análisis del caso Bargui en Aguachica, con encuesta de demanda y gestión documental.</a:t>
+            </a:r>
+          </a:p>
+          <a:p>
+            <a:pPr indent="-228600" lvl="0" marL="274320" marR="0" rtl="0" algn="l">
+              <a:lnSpc>
+                <a:spcPct val="100000"/>
+              </a:lnSpc>
+              <a:spcBef>
+                <a:spcPts val="0"/>
+              </a:spcBef>
+              <a:spcAft>
+                <a:spcPts val="400"/>
+              </a:spcAft>
+              <a:buClr>
+                <a:srgbClr val="39A935"/>
+              </a:buClr>
+              <a:buSzPct val="90000"/>
+              <a:buFont typeface="Arial"/>
+              <a:buChar char="•"/>
+            </a:pPr>
+            <a:r>
+              <a:rPr lang="es-CO" sz="1500" b="1">
+                <a:solidFill>
+                  <a:srgbClr val="262626"/>
+                </a:solidFill>
+                <a:latin typeface="Work Sans Light"/>
+                <a:ea typeface="Work Sans Light"/>
+                <a:cs typeface="Work Sans Light"/>
+                <a:sym typeface="Work Sans Light"/>
+              </a:rPr>
+              <a:t>Técnicas: </a:t>
+            </a:r>
+            <a:r>
+              <a:rPr lang="es-CO" sz="1500">
+                <a:solidFill>
+                  <a:srgbClr val="262626"/>
+                </a:solidFill>
+                <a:latin typeface="Work Sans Light"/>
+                <a:ea typeface="Work Sans Light"/>
+                <a:cs typeface="Work Sans Light"/>
+                <a:sym typeface="Work Sans Light"/>
+              </a:rPr>
+              <a:t>encuestas y revisión de documentación de la empresa.</a:t>
+            </a:r>
+          </a:p>
+          <a:p>
+            <a:pPr indent="-228600" lvl="0" marL="274320" marR="0" rtl="0" algn="l">
+              <a:lnSpc>
+                <a:spcPct val="100000"/>
+              </a:lnSpc>
+              <a:spcBef>
+                <a:spcPts val="0"/>
+              </a:spcBef>
+              <a:spcAft>
+                <a:spcPts val="0"/>
+              </a:spcAft>
+              <a:buClr>
+                <a:srgbClr val="39A935"/>
+              </a:buClr>
+              <a:buSzPct val="90000"/>
+              <a:buFont typeface="Arial"/>
+              <a:buChar char="•"/>
+            </a:pPr>
+            <a:r>
+              <a:rPr lang="es-CO" sz="1500" b="1">
+                <a:solidFill>
+                  <a:srgbClr val="262626"/>
+                </a:solidFill>
+                <a:latin typeface="Work Sans Light"/>
+                <a:ea typeface="Work Sans Light"/>
+                <a:cs typeface="Work Sans Light"/>
+                <a:sym typeface="Work Sans Light"/>
+              </a:rPr>
+              <a:t>Resultados: </a:t>
+            </a:r>
+            <a:r>
+              <a:rPr lang="es-CO" sz="1500">
+                <a:solidFill>
+                  <a:srgbClr val="262626"/>
+                </a:solidFill>
+                <a:latin typeface="Work Sans Light"/>
+                <a:ea typeface="Work Sans Light"/>
+                <a:cs typeface="Work Sans Light"/>
+                <a:sym typeface="Work Sans Light"/>
+              </a:rPr>
+              <a:t>la propuesta mostró factibilidad técnica, operativa y financiera, estructurada con el modelo CANVAS.</a:t>
+            </a:r>
+          </a:p>
+        </p:txBody>
+      </p:sp>
+      <p:sp>
+        <p:nvSpPr>
+          <p:cNvPr id="300" name="recuadro"/>
+          <p:cNvSpPr/>
+          <p:nvPr/>
+        </p:nvSpPr>
+        <p:spPr>
+          <a:xfrm>
+            <a:off x="7269480" y="1874520"/>
+            <a:ext cx="4206240" cy="4297680"/>
+          </a:xfrm>
+          <a:prstGeom prst="roundRect">
+            <a:avLst>
+              <a:gd name="adj" fmla="val 6000"/>
+            </a:avLst>
+          </a:prstGeom>
+          <a:solidFill>
+            <a:srgbClr val="EAF5E4"/>
+          </a:solidFill>
+          <a:ln w="19050">
+            <a:solidFill>
+              <a:srgbClr val="39A935"/>
+            </a:solidFill>
+          </a:ln>
+        </p:spPr>
+        <p:txBody>
+          <a:bodyPr wrap="square" lIns="182880" tIns="146304" rIns="182880" bIns="146304" anchor="t">
+            <a:noAutofit/>
+          </a:bodyPr>
+          <a:lstStyle/>
+          <a:p>
+            <a:pPr indent="0" lvl="0" marL="0" marR="0" rtl="0" algn="l">
+              <a:lnSpc>
+                <a:spcPct val="100000"/>
+              </a:lnSpc>
+              <a:spcBef>
+                <a:spcPts val="0"/>
+              </a:spcBef>
+              <a:spcAft>
+                <a:spcPts val="600"/>
+              </a:spcAft>
+              <a:buNone/>
+            </a:pPr>
+            <a:r>
+              <a:rPr lang="es-CO" sz="1700" b="1">
+                <a:solidFill>
+                  <a:srgbClr val="1F6B2E"/>
+                </a:solidFill>
+                <a:latin typeface="Work Sans Light"/>
+                <a:ea typeface="Work Sans Light"/>
+                <a:cs typeface="Work Sans Light"/>
+                <a:sym typeface="Work Sans Light"/>
+              </a:rPr>
+              <a:t>Aporte a Luna de Cristal</a:t>
+            </a:r>
+          </a:p>
+          <a:p>
+            <a:pPr indent="-228600" lvl="0" marL="274320" marR="0" rtl="0" algn="l">
+              <a:lnSpc>
+                <a:spcPct val="100000"/>
+              </a:lnSpc>
+              <a:spcBef>
+                <a:spcPts val="0"/>
+              </a:spcBef>
+              <a:spcAft>
+                <a:spcPts val="500"/>
+              </a:spcAft>
+              <a:buClr>
+                <a:srgbClr val="39A935"/>
+              </a:buClr>
+              <a:buSzPct val="90000"/>
+              <a:buFont typeface="Arial"/>
+              <a:buChar char="•"/>
+            </a:pPr>
+            <a:r>
+              <a:rPr lang="es-CO" sz="1500">
+                <a:solidFill>
+                  <a:srgbClr val="262626"/>
+                </a:solidFill>
+                <a:latin typeface="Work Sans Light"/>
+                <a:ea typeface="Work Sans Light"/>
+                <a:cs typeface="Work Sans Light"/>
+                <a:sym typeface="Work Sans Light"/>
+              </a:rPr>
+              <a:t>El análisis de la demanda femenina se puede integrar con la revisión de las operaciones y la viabilidad financiera.</a:t>
+            </a:r>
+          </a:p>
+          <a:p>
+            <a:pPr indent="-228600" lvl="0" marL="274320" marR="0" rtl="0" algn="l">
+              <a:lnSpc>
+                <a:spcPct val="100000"/>
+              </a:lnSpc>
+              <a:spcBef>
+                <a:spcPts val="0"/>
+              </a:spcBef>
+              <a:spcAft>
+                <a:spcPts val="0"/>
+              </a:spcAft>
+              <a:buClr>
+                <a:srgbClr val="39A935"/>
+              </a:buClr>
+              <a:buSzPct val="90000"/>
+              <a:buFont typeface="Arial"/>
+              <a:buChar char="•"/>
+            </a:pPr>
+            <a:r>
+              <a:rPr lang="es-CO" sz="1500">
+                <a:solidFill>
+                  <a:srgbClr val="262626"/>
+                </a:solidFill>
+                <a:latin typeface="Work Sans Light"/>
+                <a:ea typeface="Work Sans Light"/>
+                <a:cs typeface="Work Sans Light"/>
+                <a:sym typeface="Work Sans Light"/>
+              </a:rPr>
+              <a:t>El modelo CANVAS sirve para organizar la propuesta de valor del portafolio digital.</a:t>
+            </a:r>
+          </a:p>
+        </p:txBody>
+      </p:sp>
+    </p:spTree>
+  </p:cSld>
+  <p:clrMapOvr>
+    <a:masterClrMapping/>
+  </p:clrMapOvr>
+</p:sld>
+</file>
+
+<file path=ppt/slides/slide28.xml><?xml version="1.0" encoding="utf-8"?>
+<p:sld xmlns:a="http://schemas.openxmlformats.org/drawingml/2006/main" xmlns:r="http://schemas.openxmlformats.org/officeDocument/2006/relationships" xmlns:p="http://schemas.openxmlformats.org/presentationml/2006/main">
+  <p:cSld>
+    <p:bg>
+      <p:bgPr>
+        <a:blipFill>
+          <a:blip r:embed="rId3">
+            <a:alphaModFix/>
+          </a:blip>
+          <a:stretch>
+            <a:fillRect/>
+          </a:stretch>
+        </a:blipFill>
+      </p:bgPr>
+    </p:bg>
+    <p:spTree>
+      <p:nvGrpSpPr>
+        <p:cNvPr id="1" name=""/>
+        <p:cNvGrpSpPr/>
+        <p:nvPr/>
+      </p:nvGrpSpPr>
+      <p:grpSpPr>
+        <a:xfrm>
+          <a:off x="0" y="0"/>
+          <a:ext cx="0" cy="0"/>
+          <a:chOff x="0" y="0"/>
+          <a:chExt cx="0" cy="0"/>
+        </a:xfrm>
+      </p:grpSpPr>
+      <p:sp>
+        <p:nvSpPr>
+          <p:cNvPr id="158" name="encabezado"/>
+          <p:cNvSpPr txBox="1"/>
+          <p:nvPr/>
+        </p:nvSpPr>
+        <p:spPr>
+          <a:xfrm>
+            <a:off x="694944" y="868680"/>
+            <a:ext cx="10789920" cy="822960"/>
+          </a:xfrm>
+          <a:prstGeom prst="rect">
+            <a:avLst/>
+          </a:prstGeom>
+          <a:noFill/>
+          <a:ln>
+            <a:noFill/>
+          </a:ln>
+        </p:spPr>
+        <p:txBody>
+          <a:bodyPr anchorCtr="0" anchor="t" bIns="45700" lIns="91425" spcFirstLastPara="1" rIns="91425" wrap="square" tIns="45700">
+            <a:noAutofit/>
+          </a:bodyPr>
+          <a:lstStyle/>
+          <a:p>
+            <a:pPr indent="0" lvl="0" marL="0" marR="0" rtl="0" algn="l">
+              <a:lnSpc>
+                <a:spcPct val="95000"/>
+              </a:lnSpc>
+              <a:spcBef>
+                <a:spcPts val="0"/>
+              </a:spcBef>
+              <a:spcAft>
+                <a:spcPts val="0"/>
+              </a:spcAft>
+              <a:buNone/>
+            </a:pPr>
+            <a:r>
+              <a:rPr b="1" lang="es-CO" sz="3200">
+                <a:solidFill>
+                  <a:srgbClr val="4D4D4C"/>
+                </a:solidFill>
+                <a:latin typeface="Work Sans"/>
+                <a:ea typeface="Work Sans"/>
+                <a:cs typeface="Work Sans"/>
+                <a:sym typeface="Work Sans"/>
+              </a:rPr>
+              <a:t>Antecedente 3: Lago Padilla et al. (2024)</a:t>
+            </a:r>
+          </a:p>
+        </p:txBody>
+      </p:sp>
+      <p:sp>
+        <p:nvSpPr>
+          <p:cNvPr id="159" name="cuerpo"/>
+          <p:cNvSpPr txBox="1"/>
+          <p:nvPr/>
+        </p:nvSpPr>
+        <p:spPr>
+          <a:xfrm>
+            <a:off x="694944" y="1874520"/>
+            <a:ext cx="6309360" cy="4297680"/>
+          </a:xfrm>
+          <a:prstGeom prst="rect">
+            <a:avLst/>
+          </a:prstGeom>
+          <a:noFill/>
+          <a:ln>
+            <a:noFill/>
+          </a:ln>
+        </p:spPr>
+        <p:txBody>
+          <a:bodyPr anchorCtr="0" anchor="t" bIns="45700" lIns="91425" spcFirstLastPara="1" rIns="91425" wrap="square" tIns="45700">
+            <a:normAutofit/>
+          </a:bodyPr>
+          <a:lstStyle/>
+          <a:p>
+            <a:pPr indent="-228600" lvl="0" marL="274320" marR="0" rtl="0" algn="l">
+              <a:lnSpc>
+                <a:spcPct val="100000"/>
+              </a:lnSpc>
+              <a:spcBef>
+                <a:spcPts val="0"/>
+              </a:spcBef>
+              <a:spcAft>
+                <a:spcPts val="500"/>
+              </a:spcAft>
+              <a:buClr>
+                <a:srgbClr val="39A935"/>
+              </a:buClr>
+              <a:buSzPct val="90000"/>
+              <a:buFont typeface="Arial"/>
+              <a:buChar char="•"/>
+            </a:pPr>
+            <a:r>
+              <a:rPr lang="es-CO" sz="1500" b="1">
+                <a:solidFill>
+                  <a:srgbClr val="262626"/>
+                </a:solidFill>
+                <a:latin typeface="Work Sans Light"/>
+                <a:ea typeface="Work Sans Light"/>
+                <a:cs typeface="Work Sans Light"/>
+                <a:sym typeface="Work Sans Light"/>
+              </a:rPr>
+              <a:t>Estudio: </a:t>
+            </a:r>
+            <a:r>
+              <a:rPr lang="es-CO" sz="1500">
+                <a:solidFill>
+                  <a:srgbClr val="262626"/>
+                </a:solidFill>
+                <a:latin typeface="Work Sans Light"/>
+                <a:ea typeface="Work Sans Light"/>
+                <a:cs typeface="Work Sans Light"/>
+                <a:sym typeface="Work Sans Light"/>
+              </a:rPr>
+              <a:t>«Bargui y el mercado de moda femenina en Aguachica, Cesar».</a:t>
+            </a:r>
+          </a:p>
+          <a:p>
+            <a:pPr indent="-228600" lvl="0" marL="274320" marR="0" rtl="0" algn="l">
+              <a:lnSpc>
+                <a:spcPct val="100000"/>
+              </a:lnSpc>
+              <a:spcBef>
+                <a:spcPts val="0"/>
+              </a:spcBef>
+              <a:spcAft>
+                <a:spcPts val="500"/>
+              </a:spcAft>
+              <a:buClr>
+                <a:srgbClr val="39A935"/>
+              </a:buClr>
+              <a:buSzPct val="90000"/>
+              <a:buFont typeface="Arial"/>
+              <a:buChar char="•"/>
+            </a:pPr>
+            <a:r>
+              <a:rPr lang="es-CO" sz="1500" b="1">
+                <a:solidFill>
+                  <a:srgbClr val="262626"/>
+                </a:solidFill>
+                <a:latin typeface="Work Sans Light"/>
+                <a:ea typeface="Work Sans Light"/>
+                <a:cs typeface="Work Sans Light"/>
+                <a:sym typeface="Work Sans Light"/>
+              </a:rPr>
+              <a:t>Objetivo: </a:t>
+            </a:r>
+            <a:r>
+              <a:rPr lang="es-CO" sz="1500">
+                <a:solidFill>
+                  <a:srgbClr val="262626"/>
+                </a:solidFill>
+                <a:latin typeface="Work Sans Light"/>
+                <a:ea typeface="Work Sans Light"/>
+                <a:cs typeface="Work Sans Light"/>
+                <a:sym typeface="Work Sans Light"/>
+              </a:rPr>
+              <a:t>analizar el mercado, las operaciones y la viabilidad financiera de Bargui, empresa de confección de ropa femenina, para estructurar un modelo de negocio integral.</a:t>
+            </a:r>
+          </a:p>
+          <a:p>
+            <a:pPr indent="0" lvl="0" marL="0" marR="0" rtl="0" algn="l">
+              <a:lnSpc>
+                <a:spcPct val="100000"/>
+              </a:lnSpc>
+              <a:spcBef>
+                <a:spcPts val="0"/>
+              </a:spcBef>
+              <a:spcAft>
+                <a:spcPts val="200"/>
+              </a:spcAft>
+              <a:buNone/>
+            </a:pPr>
+            <a:r>
+              <a:rPr lang="es-CO" sz="1500" b="1">
+                <a:solidFill>
+                  <a:srgbClr val="262626"/>
+                </a:solidFill>
+                <a:latin typeface="Work Sans Light"/>
+                <a:ea typeface="Work Sans Light"/>
+                <a:cs typeface="Work Sans Light"/>
+                <a:sym typeface="Work Sans Light"/>
+              </a:rPr>
+              <a:t>Objetivos específicos:</a:t>
+            </a:r>
+          </a:p>
+          <a:p>
+            <a:pPr indent="-228600" lvl="0" marL="548640" marR="0" rtl="0" algn="l">
+              <a:lnSpc>
+                <a:spcPct val="100000"/>
+              </a:lnSpc>
+              <a:spcBef>
+                <a:spcPts val="0"/>
+              </a:spcBef>
+              <a:spcAft>
+                <a:spcPts val="100"/>
+              </a:spcAft>
+              <a:buClr>
+                <a:srgbClr val="39A935"/>
+              </a:buClr>
+              <a:buSzPct val="90000"/>
+              <a:buFont typeface="Arial"/>
+              <a:buChar char="–"/>
+            </a:pPr>
+            <a:r>
+              <a:rPr lang="es-CO" sz="1400">
+                <a:solidFill>
+                  <a:srgbClr val="262626"/>
+                </a:solidFill>
+                <a:latin typeface="Work Sans Light"/>
+                <a:ea typeface="Work Sans Light"/>
+                <a:cs typeface="Work Sans Light"/>
+                <a:sym typeface="Work Sans Light"/>
+              </a:rPr>
+              <a:t>Identificar el potencial de la demanda femenina mediante encuestas.</a:t>
+            </a:r>
+          </a:p>
+          <a:p>
+            <a:pPr indent="-228600" lvl="0" marL="548640" marR="0" rtl="0" algn="l">
+              <a:lnSpc>
+                <a:spcPct val="100000"/>
+              </a:lnSpc>
+              <a:spcBef>
+                <a:spcPts val="0"/>
+              </a:spcBef>
+              <a:spcAft>
+                <a:spcPts val="100"/>
+              </a:spcAft>
+              <a:buClr>
+                <a:srgbClr val="39A935"/>
+              </a:buClr>
+              <a:buSzPct val="90000"/>
+              <a:buFont typeface="Arial"/>
+              <a:buChar char="–"/>
+            </a:pPr>
+            <a:r>
+              <a:rPr lang="es-CO" sz="1400">
+                <a:solidFill>
+                  <a:srgbClr val="262626"/>
+                </a:solidFill>
+                <a:latin typeface="Work Sans Light"/>
+                <a:ea typeface="Work Sans Light"/>
+                <a:cs typeface="Work Sans Light"/>
+                <a:sym typeface="Work Sans Light"/>
+              </a:rPr>
+              <a:t>Analizar los aspectos operativos con revisión documental.</a:t>
+            </a:r>
+          </a:p>
+          <a:p>
+            <a:pPr indent="-228600" lvl="0" marL="548640" marR="0" rtl="0" algn="l">
+              <a:lnSpc>
+                <a:spcPct val="100000"/>
+              </a:lnSpc>
+              <a:spcBef>
+                <a:spcPts val="0"/>
+              </a:spcBef>
+              <a:spcAft>
+                <a:spcPts val="0"/>
+              </a:spcAft>
+              <a:buClr>
+                <a:srgbClr val="39A935"/>
+              </a:buClr>
+              <a:buSzPct val="90000"/>
+              <a:buFont typeface="Arial"/>
+              <a:buChar char="–"/>
+            </a:pPr>
+            <a:r>
+              <a:rPr lang="es-CO" sz="1400">
+                <a:solidFill>
+                  <a:srgbClr val="262626"/>
+                </a:solidFill>
+                <a:latin typeface="Work Sans Light"/>
+                <a:ea typeface="Work Sans Light"/>
+                <a:cs typeface="Work Sans Light"/>
+                <a:sym typeface="Work Sans Light"/>
+              </a:rPr>
+              <a:t>Valorar la viabilidad técnica, operativa y financiera con el modelo CANVAS.</a:t>
+            </a:r>
+          </a:p>
+        </p:txBody>
+      </p:sp>
+      <p:sp>
+        <p:nvSpPr>
+          <p:cNvPr id="300" name="recuadro"/>
+          <p:cNvSpPr/>
+          <p:nvPr/>
+        </p:nvSpPr>
+        <p:spPr>
+          <a:xfrm>
+            <a:off x="7269480" y="1874520"/>
+            <a:ext cx="4206240" cy="4297680"/>
+          </a:xfrm>
+          <a:prstGeom prst="roundRect">
+            <a:avLst>
+              <a:gd name="adj" fmla="val 6000"/>
+            </a:avLst>
+          </a:prstGeom>
+          <a:solidFill>
+            <a:srgbClr val="EAF5E4"/>
+          </a:solidFill>
+          <a:ln w="19050">
+            <a:solidFill>
+              <a:srgbClr val="39A935"/>
+            </a:solidFill>
+          </a:ln>
+        </p:spPr>
+        <p:txBody>
+          <a:bodyPr wrap="square" lIns="182880" tIns="146304" rIns="182880" bIns="146304" anchor="t">
+            <a:noAutofit/>
+          </a:bodyPr>
+          <a:lstStyle/>
+          <a:p>
+            <a:pPr indent="0" lvl="0" marL="0" marR="0" rtl="0" algn="l">
+              <a:lnSpc>
+                <a:spcPct val="100000"/>
+              </a:lnSpc>
+              <a:spcBef>
+                <a:spcPts val="0"/>
+              </a:spcBef>
+              <a:spcAft>
+                <a:spcPts val="600"/>
+              </a:spcAft>
+              <a:buNone/>
+            </a:pPr>
+            <a:r>
+              <a:rPr lang="es-CO" sz="1700" b="1">
+                <a:solidFill>
+                  <a:srgbClr val="1F6B2E"/>
+                </a:solidFill>
+                <a:latin typeface="Work Sans Light"/>
+                <a:ea typeface="Work Sans Light"/>
+                <a:cs typeface="Work Sans Light"/>
+                <a:sym typeface="Work Sans Light"/>
+              </a:rPr>
+              <a:t>Justificación</a:t>
+            </a:r>
+          </a:p>
+          <a:p>
+            <a:pPr indent="-228600" lvl="0" marL="274320" marR="0" rtl="0" algn="l">
+              <a:lnSpc>
+                <a:spcPct val="100000"/>
+              </a:lnSpc>
+              <a:spcBef>
+                <a:spcPts val="0"/>
+              </a:spcBef>
+              <a:spcAft>
+                <a:spcPts val="400"/>
+              </a:spcAft>
+              <a:buClr>
+                <a:srgbClr val="39A935"/>
+              </a:buClr>
+              <a:buSzPct val="90000"/>
+              <a:buFont typeface="Arial"/>
+              <a:buChar char="•"/>
+            </a:pPr>
+            <a:r>
+              <a:rPr lang="es-CO" sz="1500">
+                <a:solidFill>
+                  <a:srgbClr val="262626"/>
+                </a:solidFill>
+                <a:latin typeface="Work Sans Light"/>
+                <a:ea typeface="Work Sans Light"/>
+                <a:cs typeface="Work Sans Light"/>
+                <a:sym typeface="Work Sans Light"/>
+              </a:rPr>
+              <a:t>Parte del potencial de la moda femenina.</a:t>
+            </a:r>
+          </a:p>
+          <a:p>
+            <a:pPr indent="-228600" lvl="0" marL="274320" marR="0" rtl="0" algn="l">
+              <a:lnSpc>
+                <a:spcPct val="100000"/>
+              </a:lnSpc>
+              <a:spcBef>
+                <a:spcPts val="0"/>
+              </a:spcBef>
+              <a:spcAft>
+                <a:spcPts val="400"/>
+              </a:spcAft>
+              <a:buClr>
+                <a:srgbClr val="39A935"/>
+              </a:buClr>
+              <a:buSzPct val="90000"/>
+              <a:buFont typeface="Arial"/>
+              <a:buChar char="•"/>
+            </a:pPr>
+            <a:r>
+              <a:rPr lang="es-CO" sz="1500">
+                <a:solidFill>
+                  <a:srgbClr val="262626"/>
+                </a:solidFill>
+                <a:latin typeface="Work Sans Light"/>
+                <a:ea typeface="Work Sans Light"/>
+                <a:cs typeface="Work Sans Light"/>
+                <a:sym typeface="Work Sans Light"/>
+              </a:rPr>
+              <a:t>Necesidad de evaluar la demanda, las operaciones y la viabilidad financiera para fortalecer una empresa local.</a:t>
+            </a:r>
+          </a:p>
+          <a:p>
+            <a:pPr indent="-228600" lvl="0" marL="274320" marR="0" rtl="0" algn="l">
+              <a:lnSpc>
+                <a:spcPct val="100000"/>
+              </a:lnSpc>
+              <a:spcBef>
+                <a:spcPts val="0"/>
+              </a:spcBef>
+              <a:spcAft>
+                <a:spcPts val="0"/>
+              </a:spcAft>
+              <a:buClr>
+                <a:srgbClr val="39A935"/>
+              </a:buClr>
+              <a:buSzPct val="90000"/>
+              <a:buFont typeface="Arial"/>
+              <a:buChar char="•"/>
+            </a:pPr>
+            <a:r>
+              <a:rPr lang="es-CO" sz="1500">
+                <a:solidFill>
+                  <a:srgbClr val="262626"/>
+                </a:solidFill>
+                <a:latin typeface="Work Sans Light"/>
+                <a:ea typeface="Work Sans Light"/>
+                <a:cs typeface="Work Sans Light"/>
+                <a:sym typeface="Work Sans Light"/>
+              </a:rPr>
+              <a:t>Es pertinente porque estudia un caso empresarial colombiano de ropa femenina.</a:t>
+            </a:r>
+          </a:p>
+        </p:txBody>
+      </p:sp>
+    </p:spTree>
+  </p:cSld>
+  <p:clrMapOvr>
+    <a:masterClrMapping/>
+  </p:clrMapOvr>
+</p:sld>
+</file>
+
+<file path=ppt/slides/slide29.xml><?xml version="1.0" encoding="utf-8"?>
+<p:sld xmlns:a="http://schemas.openxmlformats.org/drawingml/2006/main" xmlns:r="http://schemas.openxmlformats.org/officeDocument/2006/relationships" xmlns:p="http://schemas.openxmlformats.org/presentationml/2006/main">
+  <p:cSld>
+    <p:bg>
+      <p:bgPr>
+        <a:blipFill>
+          <a:blip r:embed="rId3">
+            <a:alphaModFix/>
+          </a:blip>
+          <a:stretch>
+            <a:fillRect/>
+          </a:stretch>
+        </a:blipFill>
+      </p:bgPr>
+    </p:bg>
+    <p:spTree>
+      <p:nvGrpSpPr>
+        <p:cNvPr id="1" name=""/>
+        <p:cNvGrpSpPr/>
+        <p:nvPr/>
+      </p:nvGrpSpPr>
+      <p:grpSpPr>
+        <a:xfrm>
+          <a:off x="0" y="0"/>
+          <a:ext cx="0" cy="0"/>
+          <a:chOff x="0" y="0"/>
+          <a:chExt cx="0" cy="0"/>
+        </a:xfrm>
+      </p:grpSpPr>
+      <p:sp>
+        <p:nvSpPr>
+          <p:cNvPr id="158" name="encabezado"/>
+          <p:cNvSpPr txBox="1"/>
+          <p:nvPr/>
+        </p:nvSpPr>
+        <p:spPr>
+          <a:xfrm>
+            <a:off x="694944" y="868680"/>
+            <a:ext cx="10789920" cy="822960"/>
+          </a:xfrm>
+          <a:prstGeom prst="rect">
+            <a:avLst/>
+          </a:prstGeom>
+          <a:noFill/>
+          <a:ln>
+            <a:noFill/>
+          </a:ln>
+        </p:spPr>
+        <p:txBody>
+          <a:bodyPr anchorCtr="0" anchor="t" bIns="45700" lIns="91425" spcFirstLastPara="1" rIns="91425" wrap="square" tIns="45700">
+            <a:noAutofit/>
+          </a:bodyPr>
+          <a:lstStyle/>
+          <a:p>
+            <a:pPr indent="0" lvl="0" marL="0" marR="0" rtl="0" algn="l">
+              <a:lnSpc>
+                <a:spcPct val="95000"/>
+              </a:lnSpc>
+              <a:spcBef>
+                <a:spcPts val="0"/>
+              </a:spcBef>
+              <a:spcAft>
+                <a:spcPts val="0"/>
+              </a:spcAft>
+              <a:buNone/>
+            </a:pPr>
+            <a:r>
+              <a:rPr b="1" lang="es-CO" sz="3200">
+                <a:solidFill>
+                  <a:srgbClr val="4D4D4C"/>
+                </a:solidFill>
+                <a:latin typeface="Work Sans"/>
+                <a:ea typeface="Work Sans"/>
+                <a:cs typeface="Work Sans"/>
+                <a:sym typeface="Work Sans"/>
+              </a:rPr>
+              <a:t>Antecedente 2: diseño metodológico</a:t>
+            </a:r>
+          </a:p>
+        </p:txBody>
+      </p:sp>
+      <p:sp>
+        <p:nvSpPr>
+          <p:cNvPr id="159" name="cuerpo"/>
+          <p:cNvSpPr txBox="1"/>
+          <p:nvPr/>
+        </p:nvSpPr>
+        <p:spPr>
+          <a:xfrm>
+            <a:off x="694944" y="1874520"/>
+            <a:ext cx="6309360" cy="4297680"/>
+          </a:xfrm>
+          <a:prstGeom prst="rect">
+            <a:avLst/>
+          </a:prstGeom>
+          <a:noFill/>
+          <a:ln>
+            <a:noFill/>
+          </a:ln>
+        </p:spPr>
+        <p:txBody>
+          <a:bodyPr anchorCtr="0" anchor="t" bIns="45700" lIns="91425" spcFirstLastPara="1" rIns="91425" wrap="square" tIns="45700">
+            <a:normAutofit/>
+          </a:bodyPr>
+          <a:lstStyle/>
+          <a:p>
+            <a:pPr indent="-228600" lvl="0" marL="274320" marR="0" rtl="0" algn="l">
+              <a:lnSpc>
+                <a:spcPct val="100000"/>
+              </a:lnSpc>
+              <a:spcBef>
+                <a:spcPts val="0"/>
+              </a:spcBef>
+              <a:spcAft>
+                <a:spcPts val="400"/>
+              </a:spcAft>
+              <a:buClr>
+                <a:srgbClr val="39A935"/>
+              </a:buClr>
+              <a:buSzPct val="90000"/>
+              <a:buFont typeface="Arial"/>
+              <a:buChar char="•"/>
+            </a:pPr>
+            <a:r>
+              <a:rPr lang="es-CO" sz="1500" b="1">
+                <a:solidFill>
+                  <a:srgbClr val="262626"/>
+                </a:solidFill>
+                <a:latin typeface="Work Sans Light"/>
+                <a:ea typeface="Work Sans Light"/>
+                <a:cs typeface="Work Sans Light"/>
+                <a:sym typeface="Work Sans Light"/>
+              </a:rPr>
+              <a:t>Enfoque y tipo: </a:t>
+            </a:r>
+            <a:r>
+              <a:rPr lang="es-CO" sz="1500">
+                <a:solidFill>
+                  <a:srgbClr val="262626"/>
+                </a:solidFill>
+                <a:latin typeface="Work Sans Light"/>
+                <a:ea typeface="Work Sans Light"/>
+                <a:cs typeface="Work Sans Light"/>
+                <a:sym typeface="Work Sans Light"/>
+              </a:rPr>
+              <a:t>estudio descriptivo con enfoque mixto (encuestas y análisis documental y cualitativo).</a:t>
+            </a:r>
+          </a:p>
+          <a:p>
+            <a:pPr indent="-228600" lvl="0" marL="274320" marR="0" rtl="0" algn="l">
+              <a:lnSpc>
+                <a:spcPct val="100000"/>
+              </a:lnSpc>
+              <a:spcBef>
+                <a:spcPts val="0"/>
+              </a:spcBef>
+              <a:spcAft>
+                <a:spcPts val="400"/>
+              </a:spcAft>
+              <a:buClr>
+                <a:srgbClr val="39A935"/>
+              </a:buClr>
+              <a:buSzPct val="90000"/>
+              <a:buFont typeface="Arial"/>
+              <a:buChar char="•"/>
+            </a:pPr>
+            <a:r>
+              <a:rPr lang="es-CO" sz="1500" b="1">
+                <a:solidFill>
+                  <a:srgbClr val="262626"/>
+                </a:solidFill>
+                <a:latin typeface="Work Sans Light"/>
+                <a:ea typeface="Work Sans Light"/>
+                <a:cs typeface="Work Sans Light"/>
+                <a:sym typeface="Work Sans Light"/>
+              </a:rPr>
+              <a:t>Población y muestra: </a:t>
+            </a:r>
+            <a:r>
+              <a:rPr lang="es-CO" sz="1500">
+                <a:solidFill>
+                  <a:srgbClr val="262626"/>
+                </a:solidFill>
+                <a:latin typeface="Work Sans Light"/>
+                <a:ea typeface="Work Sans Light"/>
+                <a:cs typeface="Work Sans Light"/>
+                <a:sym typeface="Work Sans Light"/>
+              </a:rPr>
+              <a:t>mujeres de la cabecera municipal de Sahagún; cálculo de 382 encuestas.</a:t>
+            </a:r>
+          </a:p>
+          <a:p>
+            <a:pPr indent="-228600" lvl="0" marL="274320" marR="0" rtl="0" algn="l">
+              <a:lnSpc>
+                <a:spcPct val="100000"/>
+              </a:lnSpc>
+              <a:spcBef>
+                <a:spcPts val="0"/>
+              </a:spcBef>
+              <a:spcAft>
+                <a:spcPts val="400"/>
+              </a:spcAft>
+              <a:buClr>
+                <a:srgbClr val="39A935"/>
+              </a:buClr>
+              <a:buSzPct val="90000"/>
+              <a:buFont typeface="Arial"/>
+              <a:buChar char="•"/>
+            </a:pPr>
+            <a:r>
+              <a:rPr lang="es-CO" sz="1500" b="1">
+                <a:solidFill>
+                  <a:srgbClr val="262626"/>
+                </a:solidFill>
+                <a:latin typeface="Work Sans Light"/>
+                <a:ea typeface="Work Sans Light"/>
+                <a:cs typeface="Work Sans Light"/>
+                <a:sym typeface="Work Sans Light"/>
+              </a:rPr>
+              <a:t>Técnicas e instrumentos: </a:t>
+            </a:r>
+            <a:r>
+              <a:rPr lang="es-CO" sz="1500">
+                <a:solidFill>
+                  <a:srgbClr val="262626"/>
+                </a:solidFill>
+                <a:latin typeface="Work Sans Light"/>
+                <a:ea typeface="Work Sans Light"/>
+                <a:cs typeface="Work Sans Light"/>
+                <a:sym typeface="Work Sans Light"/>
+              </a:rPr>
+              <a:t>encuesta (práctica de ejercicio, frecuencia y preferencias de vestuario) y revisión documental.</a:t>
+            </a:r>
+          </a:p>
+          <a:p>
+            <a:pPr indent="-228600" lvl="0" marL="274320" marR="0" rtl="0" algn="l">
+              <a:lnSpc>
+                <a:spcPct val="100000"/>
+              </a:lnSpc>
+              <a:spcBef>
+                <a:spcPts val="0"/>
+              </a:spcBef>
+              <a:spcAft>
+                <a:spcPts val="400"/>
+              </a:spcAft>
+              <a:buClr>
+                <a:srgbClr val="39A935"/>
+              </a:buClr>
+              <a:buSzPct val="90000"/>
+              <a:buFont typeface="Arial"/>
+              <a:buChar char="•"/>
+            </a:pPr>
+            <a:r>
+              <a:rPr lang="es-CO" sz="1500" b="1">
+                <a:solidFill>
+                  <a:srgbClr val="262626"/>
+                </a:solidFill>
+                <a:latin typeface="Work Sans Light"/>
+                <a:ea typeface="Work Sans Light"/>
+                <a:cs typeface="Work Sans Light"/>
+                <a:sym typeface="Work Sans Light"/>
+              </a:rPr>
+              <a:t>Variables: </a:t>
+            </a:r>
+            <a:r>
+              <a:rPr lang="es-CO" sz="1500">
+                <a:solidFill>
+                  <a:srgbClr val="262626"/>
+                </a:solidFill>
+                <a:latin typeface="Work Sans Light"/>
+                <a:ea typeface="Work Sans Light"/>
+                <a:cs typeface="Work Sans Light"/>
+                <a:sym typeface="Work Sans Light"/>
+              </a:rPr>
+              <a:t>comportamiento de la clientela, preferencias de producto, características del mercado y factibilidad del negocio.</a:t>
+            </a:r>
+          </a:p>
+          <a:p>
+            <a:pPr indent="-228600" lvl="0" marL="274320" marR="0" rtl="0" algn="l">
+              <a:lnSpc>
+                <a:spcPct val="100000"/>
+              </a:lnSpc>
+              <a:spcBef>
+                <a:spcPts val="0"/>
+              </a:spcBef>
+              <a:spcAft>
+                <a:spcPts val="0"/>
+              </a:spcAft>
+              <a:buClr>
+                <a:srgbClr val="39A935"/>
+              </a:buClr>
+              <a:buSzPct val="90000"/>
+              <a:buFont typeface="Arial"/>
+              <a:buChar char="•"/>
+            </a:pPr>
+            <a:r>
+              <a:rPr lang="es-CO" sz="1500" b="1">
+                <a:solidFill>
+                  <a:srgbClr val="262626"/>
+                </a:solidFill>
+                <a:latin typeface="Work Sans Light"/>
+                <a:ea typeface="Work Sans Light"/>
+                <a:cs typeface="Work Sans Light"/>
+                <a:sym typeface="Work Sans Light"/>
+              </a:rPr>
+              <a:t>Análisis: </a:t>
+            </a:r>
+            <a:r>
+              <a:rPr lang="es-CO" sz="1500">
+                <a:solidFill>
+                  <a:srgbClr val="262626"/>
+                </a:solidFill>
+                <a:latin typeface="Work Sans Light"/>
+                <a:ea typeface="Work Sans Light"/>
+                <a:cs typeface="Work Sans Light"/>
+                <a:sym typeface="Work Sans Light"/>
+              </a:rPr>
+              <a:t>describe a las encuestadas, estima la demanda, la compara con la oferta y usa indicadores financieros para concluir la viabilidad.</a:t>
+            </a:r>
+          </a:p>
+        </p:txBody>
+      </p:sp>
+      <p:sp>
+        <p:nvSpPr>
+          <p:cNvPr id="300" name="recuadro"/>
+          <p:cNvSpPr/>
+          <p:nvPr/>
+        </p:nvSpPr>
+        <p:spPr>
+          <a:xfrm>
+            <a:off x="7269480" y="1874520"/>
+            <a:ext cx="4206240" cy="4297680"/>
+          </a:xfrm>
+          <a:prstGeom prst="roundRect">
+            <a:avLst>
+              <a:gd name="adj" fmla="val 6000"/>
+            </a:avLst>
+          </a:prstGeom>
+          <a:solidFill>
+            <a:srgbClr val="EAF5E4"/>
+          </a:solidFill>
+          <a:ln w="19050">
+            <a:solidFill>
+              <a:srgbClr val="39A935"/>
+            </a:solidFill>
+          </a:ln>
+        </p:spPr>
+        <p:txBody>
+          <a:bodyPr wrap="square" lIns="182880" tIns="146304" rIns="182880" bIns="146304" anchor="t">
+            <a:noAutofit/>
+          </a:bodyPr>
+          <a:lstStyle/>
+          <a:p>
+            <a:pPr indent="0" lvl="0" marL="0" marR="0" rtl="0" algn="l">
+              <a:lnSpc>
+                <a:spcPct val="100000"/>
+              </a:lnSpc>
+              <a:spcBef>
+                <a:spcPts val="0"/>
+              </a:spcBef>
+              <a:spcAft>
+                <a:spcPts val="600"/>
+              </a:spcAft>
+              <a:buNone/>
+            </a:pPr>
+            <a:r>
+              <a:rPr lang="es-CO" sz="1700" b="1">
+                <a:solidFill>
+                  <a:srgbClr val="1F6B2E"/>
+                </a:solidFill>
+                <a:latin typeface="Work Sans Light"/>
+                <a:ea typeface="Work Sans Light"/>
+                <a:cs typeface="Work Sans Light"/>
+                <a:sym typeface="Work Sans Light"/>
+              </a:rPr>
+              <a:t>Aporte a Luna de Cristal</a:t>
+            </a:r>
+          </a:p>
+          <a:p>
+            <a:pPr indent="-228600" lvl="0" marL="274320" marR="0" rtl="0" algn="l">
+              <a:lnSpc>
+                <a:spcPct val="100000"/>
+              </a:lnSpc>
+              <a:spcBef>
+                <a:spcPts val="0"/>
+              </a:spcBef>
+              <a:spcAft>
+                <a:spcPts val="500"/>
+              </a:spcAft>
+              <a:buClr>
+                <a:srgbClr val="39A935"/>
+              </a:buClr>
+              <a:buSzPct val="90000"/>
+              <a:buFont typeface="Arial"/>
+              <a:buChar char="•"/>
+            </a:pPr>
+            <a:r>
+              <a:rPr lang="es-CO" sz="1500">
+                <a:solidFill>
+                  <a:srgbClr val="262626"/>
+                </a:solidFill>
+                <a:latin typeface="Work Sans Light"/>
+                <a:ea typeface="Work Sans Light"/>
+                <a:cs typeface="Work Sans Light"/>
+                <a:sym typeface="Work Sans Light"/>
+              </a:rPr>
+              <a:t>Muestra cómo conocer a las clientas (preferencias y hábitos) antes de decidir qué ofrecer.</a:t>
+            </a:r>
+          </a:p>
+          <a:p>
+            <a:pPr indent="-228600" lvl="0" marL="274320" marR="0" rtl="0" algn="l">
+              <a:lnSpc>
+                <a:spcPct val="100000"/>
+              </a:lnSpc>
+              <a:spcBef>
+                <a:spcPts val="0"/>
+              </a:spcBef>
+              <a:spcAft>
+                <a:spcPts val="500"/>
+              </a:spcAft>
+              <a:buClr>
+                <a:srgbClr val="39A935"/>
+              </a:buClr>
+              <a:buSzPct val="90000"/>
+              <a:buFont typeface="Arial"/>
+              <a:buChar char="•"/>
+            </a:pPr>
+            <a:r>
+              <a:rPr lang="es-CO" sz="1500">
+                <a:solidFill>
+                  <a:srgbClr val="262626"/>
+                </a:solidFill>
+                <a:latin typeface="Work Sans Light"/>
+                <a:ea typeface="Work Sans Light"/>
+                <a:cs typeface="Work Sans Light"/>
+                <a:sym typeface="Work Sans Light"/>
+              </a:rPr>
+              <a:t>Confirma la estrategia de Luna de Cristal: variedad, precios cómodos y ubicación céntrica.</a:t>
+            </a:r>
+          </a:p>
+          <a:p>
+            <a:pPr indent="-228600" lvl="0" marL="274320" marR="0" rtl="0" algn="l">
+              <a:lnSpc>
+                <a:spcPct val="100000"/>
+              </a:lnSpc>
+              <a:spcBef>
+                <a:spcPts val="0"/>
+              </a:spcBef>
+              <a:spcAft>
+                <a:spcPts val="0"/>
+              </a:spcAft>
+              <a:buClr>
+                <a:srgbClr val="39A935"/>
+              </a:buClr>
+              <a:buSzPct val="90000"/>
+              <a:buFont typeface="Arial"/>
+              <a:buChar char="•"/>
+            </a:pPr>
+            <a:r>
+              <a:rPr lang="es-CO" sz="1500">
+                <a:solidFill>
+                  <a:srgbClr val="262626"/>
+                </a:solidFill>
+                <a:latin typeface="Work Sans Light"/>
+                <a:ea typeface="Work Sans Light"/>
+                <a:cs typeface="Work Sans Light"/>
+                <a:sym typeface="Work Sans Light"/>
+              </a:rPr>
+              <a:t>Enseña a comparar demanda y oferta y a revisar costos antes de invertir.</a:t>
+            </a:r>
+          </a:p>
+        </p:txBody>
+      </p:sp>
+    </p:spTree>
+  </p:cSld>
+  <p:clrMapOvr>
+    <a:masterClrMapping/>
+  </p:clrMapOvr>
+</p:sld>
+</file>
+
 <file path=ppt/slides/slide3.xml><?xml version="1.0" encoding="utf-8"?>
 <p:sld xmlns:a="http://schemas.openxmlformats.org/drawingml/2006/main" xmlns:r="http://schemas.openxmlformats.org/officeDocument/2006/relationships" xmlns:p="http://schemas.openxmlformats.org/presentationml/2006/main">
   <p:cSld>
@@ -16146,6 +18001,1712 @@
           </a:effectLst>
         </p:spPr>
       </p:pic>
+    </p:spTree>
+  </p:cSld>
+  <p:clrMapOvr>
+    <a:masterClrMapping/>
+  </p:clrMapOvr>
+</p:sld>
+</file>
+
+<file path=ppt/slides/slide30.xml><?xml version="1.0" encoding="utf-8"?>
+<p:sld xmlns:a="http://schemas.openxmlformats.org/drawingml/2006/main" xmlns:r="http://schemas.openxmlformats.org/officeDocument/2006/relationships" xmlns:p="http://schemas.openxmlformats.org/presentationml/2006/main">
+  <p:cSld>
+    <p:bg>
+      <p:bgPr>
+        <a:blipFill>
+          <a:blip r:embed="rId3">
+            <a:alphaModFix/>
+          </a:blip>
+          <a:stretch>
+            <a:fillRect/>
+          </a:stretch>
+        </a:blipFill>
+      </p:bgPr>
+    </p:bg>
+    <p:spTree>
+      <p:nvGrpSpPr>
+        <p:cNvPr id="1" name=""/>
+        <p:cNvGrpSpPr/>
+        <p:nvPr/>
+      </p:nvGrpSpPr>
+      <p:grpSpPr>
+        <a:xfrm>
+          <a:off x="0" y="0"/>
+          <a:ext cx="0" cy="0"/>
+          <a:chOff x="0" y="0"/>
+          <a:chExt cx="0" cy="0"/>
+        </a:xfrm>
+      </p:grpSpPr>
+      <p:sp>
+        <p:nvSpPr>
+          <p:cNvPr id="158" name="encabezado"/>
+          <p:cNvSpPr txBox="1"/>
+          <p:nvPr/>
+        </p:nvSpPr>
+        <p:spPr>
+          <a:xfrm>
+            <a:off x="694944" y="868680"/>
+            <a:ext cx="10789920" cy="822960"/>
+          </a:xfrm>
+          <a:prstGeom prst="rect">
+            <a:avLst/>
+          </a:prstGeom>
+          <a:noFill/>
+          <a:ln>
+            <a:noFill/>
+          </a:ln>
+        </p:spPr>
+        <p:txBody>
+          <a:bodyPr anchorCtr="0" anchor="t" bIns="45700" lIns="91425" spcFirstLastPara="1" rIns="91425" wrap="square" tIns="45700">
+            <a:noAutofit/>
+          </a:bodyPr>
+          <a:lstStyle/>
+          <a:p>
+            <a:pPr indent="0" lvl="0" marL="0" marR="0" rtl="0" algn="l">
+              <a:lnSpc>
+                <a:spcPct val="95000"/>
+              </a:lnSpc>
+              <a:spcBef>
+                <a:spcPts val="0"/>
+              </a:spcBef>
+              <a:spcAft>
+                <a:spcPts val="0"/>
+              </a:spcAft>
+              <a:buNone/>
+            </a:pPr>
+            <a:r>
+              <a:rPr b="1" lang="es-CO" sz="3200">
+                <a:solidFill>
+                  <a:srgbClr val="4D4D4C"/>
+                </a:solidFill>
+                <a:latin typeface="Work Sans"/>
+                <a:ea typeface="Work Sans"/>
+                <a:cs typeface="Work Sans"/>
+                <a:sym typeface="Work Sans"/>
+              </a:rPr>
+              <a:t>Antecedente 2: Fuentes y Mejía (2021)</a:t>
+            </a:r>
+          </a:p>
+        </p:txBody>
+      </p:sp>
+      <p:sp>
+        <p:nvSpPr>
+          <p:cNvPr id="159" name="cuerpo"/>
+          <p:cNvSpPr txBox="1"/>
+          <p:nvPr/>
+        </p:nvSpPr>
+        <p:spPr>
+          <a:xfrm>
+            <a:off x="694944" y="1874520"/>
+            <a:ext cx="6309360" cy="4297680"/>
+          </a:xfrm>
+          <a:prstGeom prst="rect">
+            <a:avLst/>
+          </a:prstGeom>
+          <a:noFill/>
+          <a:ln>
+            <a:noFill/>
+          </a:ln>
+        </p:spPr>
+        <p:txBody>
+          <a:bodyPr anchorCtr="0" anchor="t" bIns="45700" lIns="91425" spcFirstLastPara="1" rIns="91425" wrap="square" tIns="45700">
+            <a:normAutofit/>
+          </a:bodyPr>
+          <a:lstStyle/>
+          <a:p>
+            <a:pPr indent="-228600" lvl="0" marL="274320" marR="0" rtl="0" algn="l">
+              <a:lnSpc>
+                <a:spcPct val="100000"/>
+              </a:lnSpc>
+              <a:spcBef>
+                <a:spcPts val="0"/>
+              </a:spcBef>
+              <a:spcAft>
+                <a:spcPts val="500"/>
+              </a:spcAft>
+              <a:buClr>
+                <a:srgbClr val="39A935"/>
+              </a:buClr>
+              <a:buSzPct val="90000"/>
+              <a:buFont typeface="Arial"/>
+              <a:buChar char="•"/>
+            </a:pPr>
+            <a:r>
+              <a:rPr lang="es-CO" sz="1500" b="1">
+                <a:solidFill>
+                  <a:srgbClr val="262626"/>
+                </a:solidFill>
+                <a:latin typeface="Work Sans Light"/>
+                <a:ea typeface="Work Sans Light"/>
+                <a:cs typeface="Work Sans Light"/>
+                <a:sym typeface="Work Sans Light"/>
+              </a:rPr>
+              <a:t>Estudio: </a:t>
+            </a:r>
+            <a:r>
+              <a:rPr lang="es-CO" sz="1500">
+                <a:solidFill>
+                  <a:srgbClr val="262626"/>
+                </a:solidFill>
+                <a:latin typeface="Work Sans Light"/>
+                <a:ea typeface="Work Sans Light"/>
+                <a:cs typeface="Work Sans Light"/>
+                <a:sym typeface="Work Sans Light"/>
+              </a:rPr>
+              <a:t>Creación de una empresa dedicada a la comercialización de ropa deportiva femenina en Sahagún, Córdoba (Marina Sport).</a:t>
+            </a:r>
+          </a:p>
+          <a:p>
+            <a:pPr indent="-228600" lvl="0" marL="274320" marR="0" rtl="0" algn="l">
+              <a:lnSpc>
+                <a:spcPct val="100000"/>
+              </a:lnSpc>
+              <a:spcBef>
+                <a:spcPts val="0"/>
+              </a:spcBef>
+              <a:spcAft>
+                <a:spcPts val="500"/>
+              </a:spcAft>
+              <a:buClr>
+                <a:srgbClr val="39A935"/>
+              </a:buClr>
+              <a:buSzPct val="90000"/>
+              <a:buFont typeface="Arial"/>
+              <a:buChar char="•"/>
+            </a:pPr>
+            <a:r>
+              <a:rPr lang="es-CO" sz="1500" b="1">
+                <a:solidFill>
+                  <a:srgbClr val="262626"/>
+                </a:solidFill>
+                <a:latin typeface="Work Sans Light"/>
+                <a:ea typeface="Work Sans Light"/>
+                <a:cs typeface="Work Sans Light"/>
+                <a:sym typeface="Work Sans Light"/>
+              </a:rPr>
+              <a:t>Objetivo general: </a:t>
+            </a:r>
+            <a:r>
+              <a:rPr lang="es-CO" sz="1500">
+                <a:solidFill>
+                  <a:srgbClr val="262626"/>
+                </a:solidFill>
+                <a:latin typeface="Work Sans Light"/>
+                <a:ea typeface="Work Sans Light"/>
+                <a:cs typeface="Work Sans Light"/>
+                <a:sym typeface="Work Sans Light"/>
+              </a:rPr>
+              <a:t>determinar la viabilidad de crear la empresa Marina Sport.</a:t>
+            </a:r>
+          </a:p>
+          <a:p>
+            <a:pPr indent="0" lvl="0" marL="0" marR="0" rtl="0" algn="l">
+              <a:lnSpc>
+                <a:spcPct val="100000"/>
+              </a:lnSpc>
+              <a:spcBef>
+                <a:spcPts val="0"/>
+              </a:spcBef>
+              <a:spcAft>
+                <a:spcPts val="200"/>
+              </a:spcAft>
+              <a:buNone/>
+            </a:pPr>
+            <a:r>
+              <a:rPr lang="es-CO" sz="1500" b="1">
+                <a:solidFill>
+                  <a:srgbClr val="262626"/>
+                </a:solidFill>
+                <a:latin typeface="Work Sans Light"/>
+                <a:ea typeface="Work Sans Light"/>
+                <a:cs typeface="Work Sans Light"/>
+                <a:sym typeface="Work Sans Light"/>
+              </a:rPr>
+              <a:t>Objetivos específicos:</a:t>
+            </a:r>
+          </a:p>
+          <a:p>
+            <a:pPr indent="-228600" lvl="0" marL="548640" marR="0" rtl="0" algn="l">
+              <a:lnSpc>
+                <a:spcPct val="100000"/>
+              </a:lnSpc>
+              <a:spcBef>
+                <a:spcPts val="0"/>
+              </a:spcBef>
+              <a:spcAft>
+                <a:spcPts val="100"/>
+              </a:spcAft>
+              <a:buClr>
+                <a:srgbClr val="39A935"/>
+              </a:buClr>
+              <a:buSzPct val="90000"/>
+              <a:buFont typeface="Arial"/>
+              <a:buChar char="–"/>
+            </a:pPr>
+            <a:r>
+              <a:rPr lang="es-CO" sz="1400">
+                <a:solidFill>
+                  <a:srgbClr val="262626"/>
+                </a:solidFill>
+                <a:latin typeface="Work Sans Light"/>
+                <a:ea typeface="Work Sans Light"/>
+                <a:cs typeface="Work Sans Light"/>
+                <a:sym typeface="Work Sans Light"/>
+              </a:rPr>
+              <a:t>Analizar el mercado local: demanda, oferta, precios y competidores.</a:t>
+            </a:r>
+          </a:p>
+          <a:p>
+            <a:pPr indent="-228600" lvl="0" marL="548640" marR="0" rtl="0" algn="l">
+              <a:lnSpc>
+                <a:spcPct val="100000"/>
+              </a:lnSpc>
+              <a:spcBef>
+                <a:spcPts val="0"/>
+              </a:spcBef>
+              <a:spcAft>
+                <a:spcPts val="100"/>
+              </a:spcAft>
+              <a:buClr>
+                <a:srgbClr val="39A935"/>
+              </a:buClr>
+              <a:buSzPct val="90000"/>
+              <a:buFont typeface="Arial"/>
+              <a:buChar char="–"/>
+            </a:pPr>
+            <a:r>
+              <a:rPr lang="es-CO" sz="1400">
+                <a:solidFill>
+                  <a:srgbClr val="262626"/>
+                </a:solidFill>
+                <a:latin typeface="Work Sans Light"/>
+                <a:ea typeface="Work Sans Light"/>
+                <a:cs typeface="Work Sans Light"/>
+                <a:sym typeface="Work Sans Light"/>
+              </a:rPr>
+              <a:t>Examinar a las potenciales clientas y sus hábitos.</a:t>
+            </a:r>
+          </a:p>
+          <a:p>
+            <a:pPr indent="-228600" lvl="0" marL="548640" marR="0" rtl="0" algn="l">
+              <a:lnSpc>
+                <a:spcPct val="100000"/>
+              </a:lnSpc>
+              <a:spcBef>
+                <a:spcPts val="0"/>
+              </a:spcBef>
+              <a:spcAft>
+                <a:spcPts val="100"/>
+              </a:spcAft>
+              <a:buClr>
+                <a:srgbClr val="39A935"/>
+              </a:buClr>
+              <a:buSzPct val="90000"/>
+              <a:buFont typeface="Arial"/>
+              <a:buChar char="–"/>
+            </a:pPr>
+            <a:r>
+              <a:rPr lang="es-CO" sz="1400">
+                <a:solidFill>
+                  <a:srgbClr val="262626"/>
+                </a:solidFill>
+                <a:latin typeface="Work Sans Light"/>
+                <a:ea typeface="Work Sans Light"/>
+                <a:cs typeface="Work Sans Light"/>
+                <a:sym typeface="Work Sans Light"/>
+              </a:rPr>
+              <a:t>Identificar efectos sociales y económicos (empleo).</a:t>
+            </a:r>
+          </a:p>
+          <a:p>
+            <a:pPr indent="-228600" lvl="0" marL="548640" marR="0" rtl="0" algn="l">
+              <a:lnSpc>
+                <a:spcPct val="100000"/>
+              </a:lnSpc>
+              <a:spcBef>
+                <a:spcPts val="0"/>
+              </a:spcBef>
+              <a:spcAft>
+                <a:spcPts val="100"/>
+              </a:spcAft>
+              <a:buClr>
+                <a:srgbClr val="39A935"/>
+              </a:buClr>
+              <a:buSzPct val="90000"/>
+              <a:buFont typeface="Arial"/>
+              <a:buChar char="–"/>
+            </a:pPr>
+            <a:r>
+              <a:rPr lang="es-CO" sz="1400">
+                <a:solidFill>
+                  <a:srgbClr val="262626"/>
+                </a:solidFill>
+                <a:latin typeface="Work Sans Light"/>
+                <a:ea typeface="Work Sans Light"/>
+                <a:cs typeface="Work Sans Light"/>
+                <a:sym typeface="Work Sans Light"/>
+              </a:rPr>
+              <a:t>Definir aspectos técnicos y organizacionales.</a:t>
+            </a:r>
+          </a:p>
+          <a:p>
+            <a:pPr indent="-228600" lvl="0" marL="548640" marR="0" rtl="0" algn="l">
+              <a:lnSpc>
+                <a:spcPct val="100000"/>
+              </a:lnSpc>
+              <a:spcBef>
+                <a:spcPts val="0"/>
+              </a:spcBef>
+              <a:spcAft>
+                <a:spcPts val="0"/>
+              </a:spcAft>
+              <a:buClr>
+                <a:srgbClr val="39A935"/>
+              </a:buClr>
+              <a:buSzPct val="90000"/>
+              <a:buFont typeface="Arial"/>
+              <a:buChar char="–"/>
+            </a:pPr>
+            <a:r>
+              <a:rPr lang="es-CO" sz="1400">
+                <a:solidFill>
+                  <a:srgbClr val="262626"/>
+                </a:solidFill>
+                <a:latin typeface="Work Sans Light"/>
+                <a:ea typeface="Work Sans Light"/>
+                <a:cs typeface="Work Sans Light"/>
+                <a:sym typeface="Work Sans Light"/>
+              </a:rPr>
+              <a:t>Estimar la factibilidad financiera.</a:t>
+            </a:r>
+          </a:p>
+        </p:txBody>
+      </p:sp>
+      <p:sp>
+        <p:nvSpPr>
+          <p:cNvPr id="300" name="recuadro"/>
+          <p:cNvSpPr/>
+          <p:nvPr/>
+        </p:nvSpPr>
+        <p:spPr>
+          <a:xfrm>
+            <a:off x="7269480" y="1874520"/>
+            <a:ext cx="4206240" cy="4297680"/>
+          </a:xfrm>
+          <a:prstGeom prst="roundRect">
+            <a:avLst>
+              <a:gd name="adj" fmla="val 6000"/>
+            </a:avLst>
+          </a:prstGeom>
+          <a:solidFill>
+            <a:srgbClr val="EAF5E4"/>
+          </a:solidFill>
+          <a:ln w="19050">
+            <a:solidFill>
+              <a:srgbClr val="39A935"/>
+            </a:solidFill>
+          </a:ln>
+        </p:spPr>
+        <p:txBody>
+          <a:bodyPr wrap="square" lIns="182880" tIns="146304" rIns="182880" bIns="146304" anchor="t">
+            <a:noAutofit/>
+          </a:bodyPr>
+          <a:lstStyle/>
+          <a:p>
+            <a:pPr indent="0" lvl="0" marL="0" marR="0" rtl="0" algn="l">
+              <a:lnSpc>
+                <a:spcPct val="100000"/>
+              </a:lnSpc>
+              <a:spcBef>
+                <a:spcPts val="0"/>
+              </a:spcBef>
+              <a:spcAft>
+                <a:spcPts val="600"/>
+              </a:spcAft>
+              <a:buNone/>
+            </a:pPr>
+            <a:r>
+              <a:rPr lang="es-CO" sz="1700" b="1">
+                <a:solidFill>
+                  <a:srgbClr val="1F6B2E"/>
+                </a:solidFill>
+                <a:latin typeface="Work Sans Light"/>
+                <a:ea typeface="Work Sans Light"/>
+                <a:cs typeface="Work Sans Light"/>
+                <a:sym typeface="Work Sans Light"/>
+              </a:rPr>
+              <a:t>Justificación</a:t>
+            </a:r>
+          </a:p>
+          <a:p>
+            <a:pPr indent="-228600" lvl="0" marL="274320" marR="0" rtl="0" algn="l">
+              <a:lnSpc>
+                <a:spcPct val="100000"/>
+              </a:lnSpc>
+              <a:spcBef>
+                <a:spcPts val="0"/>
+              </a:spcBef>
+              <a:spcAft>
+                <a:spcPts val="400"/>
+              </a:spcAft>
+              <a:buClr>
+                <a:srgbClr val="39A935"/>
+              </a:buClr>
+              <a:buSzPct val="90000"/>
+              <a:buFont typeface="Arial"/>
+              <a:buChar char="•"/>
+            </a:pPr>
+            <a:r>
+              <a:rPr lang="es-CO" sz="1500">
+                <a:solidFill>
+                  <a:srgbClr val="262626"/>
+                </a:solidFill>
+                <a:latin typeface="Work Sans Light"/>
+                <a:ea typeface="Work Sans Light"/>
+                <a:cs typeface="Work Sans Light"/>
+                <a:sym typeface="Work Sans Light"/>
+              </a:rPr>
+              <a:t>Atender la necesidad de vestuario deportivo cómodo para las mujeres de Sahagún.</a:t>
+            </a:r>
+          </a:p>
+          <a:p>
+            <a:pPr indent="-228600" lvl="0" marL="274320" marR="0" rtl="0" algn="l">
+              <a:lnSpc>
+                <a:spcPct val="100000"/>
+              </a:lnSpc>
+              <a:spcBef>
+                <a:spcPts val="0"/>
+              </a:spcBef>
+              <a:spcAft>
+                <a:spcPts val="400"/>
+              </a:spcAft>
+              <a:buClr>
+                <a:srgbClr val="39A935"/>
+              </a:buClr>
+              <a:buSzPct val="90000"/>
+              <a:buFont typeface="Arial"/>
+              <a:buChar char="•"/>
+            </a:pPr>
+            <a:r>
+              <a:rPr lang="es-CO" sz="1500">
+                <a:solidFill>
+                  <a:srgbClr val="262626"/>
+                </a:solidFill>
+                <a:latin typeface="Work Sans Light"/>
+                <a:ea typeface="Work Sans Light"/>
+                <a:cs typeface="Work Sans Light"/>
+                <a:sym typeface="Work Sans Light"/>
+              </a:rPr>
+              <a:t>Diferenciarse con variedad de diseños, tallas y precios, en una zona céntrica.</a:t>
+            </a:r>
+          </a:p>
+          <a:p>
+            <a:pPr indent="-228600" lvl="0" marL="274320" marR="0" rtl="0" algn="l">
+              <a:lnSpc>
+                <a:spcPct val="100000"/>
+              </a:lnSpc>
+              <a:spcBef>
+                <a:spcPts val="0"/>
+              </a:spcBef>
+              <a:spcAft>
+                <a:spcPts val="400"/>
+              </a:spcAft>
+              <a:buClr>
+                <a:srgbClr val="39A935"/>
+              </a:buClr>
+              <a:buSzPct val="90000"/>
+              <a:buFont typeface="Arial"/>
+              <a:buChar char="•"/>
+            </a:pPr>
+            <a:r>
+              <a:rPr lang="es-CO" sz="1500">
+                <a:solidFill>
+                  <a:srgbClr val="262626"/>
+                </a:solidFill>
+                <a:latin typeface="Work Sans Light"/>
+                <a:ea typeface="Work Sans Light"/>
+                <a:cs typeface="Work Sans Light"/>
+                <a:sym typeface="Work Sans Light"/>
+              </a:rPr>
+              <a:t>Generar empleo y dinamizar la economía local; empaques biodegradables y prendas de algodón.</a:t>
+            </a:r>
+          </a:p>
+          <a:p>
+            <a:pPr indent="-228600" lvl="0" marL="274320" marR="0" rtl="0" algn="l">
+              <a:lnSpc>
+                <a:spcPct val="100000"/>
+              </a:lnSpc>
+              <a:spcBef>
+                <a:spcPts val="0"/>
+              </a:spcBef>
+              <a:spcAft>
+                <a:spcPts val="0"/>
+              </a:spcAft>
+              <a:buClr>
+                <a:srgbClr val="39A935"/>
+              </a:buClr>
+              <a:buSzPct val="90000"/>
+              <a:buFont typeface="Arial"/>
+              <a:buChar char="•"/>
+            </a:pPr>
+            <a:r>
+              <a:rPr lang="es-CO" sz="1500">
+                <a:solidFill>
+                  <a:srgbClr val="262626"/>
+                </a:solidFill>
+                <a:latin typeface="Work Sans Light"/>
+                <a:ea typeface="Work Sans Light"/>
+                <a:cs typeface="Work Sans Light"/>
+                <a:sym typeface="Work Sans Light"/>
+              </a:rPr>
+              <a:t>Evaluar lo técnico, organizacional y financiero para pasar de una idea a una decisión informada.</a:t>
+            </a:r>
+          </a:p>
+        </p:txBody>
+      </p:sp>
+    </p:spTree>
+  </p:cSld>
+  <p:clrMapOvr>
+    <a:masterClrMapping/>
+  </p:clrMapOvr>
+</p:sld>
+</file>
+
+<file path=ppt/slides/slide31.xml><?xml version="1.0" encoding="utf-8"?>
+<p:sld xmlns:a="http://schemas.openxmlformats.org/drawingml/2006/main" xmlns:r="http://schemas.openxmlformats.org/officeDocument/2006/relationships" xmlns:p="http://schemas.openxmlformats.org/presentationml/2006/main">
+  <p:cSld>
+    <p:bg>
+      <p:bgPr>
+        <a:blipFill>
+          <a:blip r:embed="rId3">
+            <a:alphaModFix/>
+          </a:blip>
+          <a:stretch>
+            <a:fillRect/>
+          </a:stretch>
+        </a:blipFill>
+      </p:bgPr>
+    </p:bg>
+    <p:spTree>
+      <p:nvGrpSpPr>
+        <p:cNvPr id="1" name=""/>
+        <p:cNvGrpSpPr/>
+        <p:nvPr/>
+      </p:nvGrpSpPr>
+      <p:grpSpPr>
+        <a:xfrm>
+          <a:off x="0" y="0"/>
+          <a:ext cx="0" cy="0"/>
+          <a:chOff x="0" y="0"/>
+          <a:chExt cx="0" cy="0"/>
+        </a:xfrm>
+      </p:grpSpPr>
+      <p:sp>
+        <p:nvSpPr>
+          <p:cNvPr id="158" name="encabezado"/>
+          <p:cNvSpPr txBox="1"/>
+          <p:nvPr/>
+        </p:nvSpPr>
+        <p:spPr>
+          <a:xfrm>
+            <a:off x="694944" y="868680"/>
+            <a:ext cx="10789920" cy="822960"/>
+          </a:xfrm>
+          <a:prstGeom prst="rect">
+            <a:avLst/>
+          </a:prstGeom>
+          <a:noFill/>
+          <a:ln>
+            <a:noFill/>
+          </a:ln>
+        </p:spPr>
+        <p:txBody>
+          <a:bodyPr anchorCtr="0" anchor="t" bIns="45700" lIns="91425" spcFirstLastPara="1" rIns="91425" wrap="square" tIns="45700">
+            <a:noAutofit/>
+          </a:bodyPr>
+          <a:lstStyle/>
+          <a:p>
+            <a:pPr indent="0" lvl="0" marL="0" marR="0" rtl="0" algn="l">
+              <a:lnSpc>
+                <a:spcPct val="95000"/>
+              </a:lnSpc>
+              <a:spcBef>
+                <a:spcPts val="0"/>
+              </a:spcBef>
+              <a:spcAft>
+                <a:spcPts val="0"/>
+              </a:spcAft>
+              <a:buNone/>
+            </a:pPr>
+            <a:r>
+              <a:rPr b="1" lang="es-CO" sz="3200">
+                <a:solidFill>
+                  <a:srgbClr val="4D4D4C"/>
+                </a:solidFill>
+                <a:latin typeface="Work Sans"/>
+                <a:ea typeface="Work Sans"/>
+                <a:cs typeface="Work Sans"/>
+                <a:sym typeface="Work Sans"/>
+              </a:rPr>
+              <a:t>Antecedente 1: Gallego y Durán (2024)</a:t>
+            </a:r>
+          </a:p>
+        </p:txBody>
+      </p:sp>
+      <p:sp>
+        <p:nvSpPr>
+          <p:cNvPr id="159" name="cuerpo"/>
+          <p:cNvSpPr txBox="1"/>
+          <p:nvPr/>
+        </p:nvSpPr>
+        <p:spPr>
+          <a:xfrm>
+            <a:off x="694944" y="1874520"/>
+            <a:ext cx="6309360" cy="4297680"/>
+          </a:xfrm>
+          <a:prstGeom prst="rect">
+            <a:avLst/>
+          </a:prstGeom>
+          <a:noFill/>
+          <a:ln>
+            <a:noFill/>
+          </a:ln>
+        </p:spPr>
+        <p:txBody>
+          <a:bodyPr anchorCtr="0" anchor="t" bIns="45700" lIns="91425" spcFirstLastPara="1" rIns="91425" wrap="square" tIns="45700">
+            <a:normAutofit/>
+          </a:bodyPr>
+          <a:lstStyle/>
+          <a:p>
+            <a:pPr indent="-228600" lvl="0" marL="274320" marR="0" rtl="0" algn="l">
+              <a:lnSpc>
+                <a:spcPct val="100000"/>
+              </a:lnSpc>
+              <a:spcBef>
+                <a:spcPts val="0"/>
+              </a:spcBef>
+              <a:spcAft>
+                <a:spcPts val="400"/>
+              </a:spcAft>
+              <a:buClr>
+                <a:srgbClr val="39A935"/>
+              </a:buClr>
+              <a:buSzPct val="90000"/>
+              <a:buFont typeface="Arial"/>
+              <a:buChar char="•"/>
+            </a:pPr>
+            <a:r>
+              <a:rPr lang="es-CO" sz="1500" b="1">
+                <a:solidFill>
+                  <a:srgbClr val="262626"/>
+                </a:solidFill>
+                <a:latin typeface="Work Sans Light"/>
+                <a:ea typeface="Work Sans Light"/>
+                <a:cs typeface="Work Sans Light"/>
+                <a:sym typeface="Work Sans Light"/>
+              </a:rPr>
+              <a:t>Estudio: </a:t>
+            </a:r>
+            <a:r>
+              <a:rPr lang="es-CO" sz="1500">
+                <a:solidFill>
+                  <a:srgbClr val="262626"/>
+                </a:solidFill>
+                <a:latin typeface="Work Sans Light"/>
+                <a:ea typeface="Work Sans Light"/>
+                <a:cs typeface="Work Sans Light"/>
+                <a:sym typeface="Work Sans Light"/>
+              </a:rPr>
+              <a:t>«Estudio de mercado para identificar el interés de las pequeñas empresas del sector textil y moda del Altiplano del Oriente Antioqueño en adquirir una aplicación tecnológica…». Universidad Católica de Oriente, Rionegro.</a:t>
+            </a:r>
+          </a:p>
+          <a:p>
+            <a:pPr indent="-228600" lvl="0" marL="274320" marR="0" rtl="0" algn="l">
+              <a:lnSpc>
+                <a:spcPct val="100000"/>
+              </a:lnSpc>
+              <a:spcBef>
+                <a:spcPts val="0"/>
+              </a:spcBef>
+              <a:spcAft>
+                <a:spcPts val="400"/>
+              </a:spcAft>
+              <a:buClr>
+                <a:srgbClr val="39A935"/>
+              </a:buClr>
+              <a:buSzPct val="90000"/>
+              <a:buFont typeface="Arial"/>
+              <a:buChar char="•"/>
+            </a:pPr>
+            <a:r>
+              <a:rPr lang="es-CO" sz="1500" b="1">
+                <a:solidFill>
+                  <a:srgbClr val="262626"/>
+                </a:solidFill>
+                <a:latin typeface="Work Sans Light"/>
+                <a:ea typeface="Work Sans Light"/>
+                <a:cs typeface="Work Sans Light"/>
+                <a:sym typeface="Work Sans Light"/>
+              </a:rPr>
+              <a:t>Metodología: </a:t>
+            </a:r>
+            <a:r>
+              <a:rPr lang="es-CO" sz="1500">
+                <a:solidFill>
+                  <a:srgbClr val="262626"/>
+                </a:solidFill>
+                <a:latin typeface="Work Sans Light"/>
+                <a:ea typeface="Work Sans Light"/>
+                <a:cs typeface="Work Sans Light"/>
+                <a:sym typeface="Work Sans Light"/>
+              </a:rPr>
+              <a:t>enfoque cualitativo, descriptivo y exploratorio; entrevistas semiestructuradas a profundidad a empresarios del sector y tablas cruzadas.</a:t>
+            </a:r>
+          </a:p>
+          <a:p>
+            <a:pPr indent="-228600" lvl="0" marL="274320" marR="0" rtl="0" algn="l">
+              <a:lnSpc>
+                <a:spcPct val="100000"/>
+              </a:lnSpc>
+              <a:spcBef>
+                <a:spcPts val="0"/>
+              </a:spcBef>
+              <a:spcAft>
+                <a:spcPts val="400"/>
+              </a:spcAft>
+              <a:buClr>
+                <a:srgbClr val="39A935"/>
+              </a:buClr>
+              <a:buSzPct val="90000"/>
+              <a:buFont typeface="Arial"/>
+              <a:buChar char="•"/>
+            </a:pPr>
+            <a:r>
+              <a:rPr lang="es-CO" sz="1500" b="1">
+                <a:solidFill>
+                  <a:srgbClr val="262626"/>
+                </a:solidFill>
+                <a:latin typeface="Work Sans Light"/>
+                <a:ea typeface="Work Sans Light"/>
+                <a:cs typeface="Work Sans Light"/>
+                <a:sym typeface="Work Sans Light"/>
+              </a:rPr>
+              <a:t>Hallazgos: </a:t>
+            </a:r>
+            <a:r>
+              <a:rPr lang="es-CO" sz="1500">
+                <a:solidFill>
+                  <a:srgbClr val="262626"/>
+                </a:solidFill>
+                <a:latin typeface="Work Sans Light"/>
+                <a:ea typeface="Work Sans Light"/>
+                <a:cs typeface="Work Sans Light"/>
+                <a:sym typeface="Work Sans Light"/>
+              </a:rPr>
+              <a:t>el 100 % de las empresas prefiere herramientas visuales, fáciles de usar y compatibles con facturación, inventarios, códigos QR e Instagram.</a:t>
+            </a:r>
+          </a:p>
+        </p:txBody>
+      </p:sp>
+      <p:sp>
+        <p:nvSpPr>
+          <p:cNvPr id="300" name="recuadro"/>
+          <p:cNvSpPr/>
+          <p:nvPr/>
+        </p:nvSpPr>
+        <p:spPr>
+          <a:xfrm>
+            <a:off x="7269480" y="1874520"/>
+            <a:ext cx="4206240" cy="4297680"/>
+          </a:xfrm>
+          <a:prstGeom prst="roundRect">
+            <a:avLst>
+              <a:gd name="adj" fmla="val 6000"/>
+            </a:avLst>
+          </a:prstGeom>
+          <a:solidFill>
+            <a:srgbClr val="EAF5E4"/>
+          </a:solidFill>
+          <a:ln w="19050">
+            <a:solidFill>
+              <a:srgbClr val="39A935"/>
+            </a:solidFill>
+          </a:ln>
+        </p:spPr>
+        <p:txBody>
+          <a:bodyPr wrap="square" lIns="182880" tIns="146304" rIns="182880" bIns="146304" anchor="t">
+            <a:noAutofit/>
+          </a:bodyPr>
+          <a:lstStyle/>
+          <a:p>
+            <a:pPr indent="0" lvl="0" marL="0" marR="0" rtl="0" algn="l">
+              <a:lnSpc>
+                <a:spcPct val="100000"/>
+              </a:lnSpc>
+              <a:spcBef>
+                <a:spcPts val="0"/>
+              </a:spcBef>
+              <a:spcAft>
+                <a:spcPts val="600"/>
+              </a:spcAft>
+              <a:buNone/>
+            </a:pPr>
+            <a:r>
+              <a:rPr lang="es-CO" sz="1700" b="1">
+                <a:solidFill>
+                  <a:srgbClr val="1F6B2E"/>
+                </a:solidFill>
+                <a:latin typeface="Work Sans Light"/>
+                <a:ea typeface="Work Sans Light"/>
+                <a:cs typeface="Work Sans Light"/>
+                <a:sym typeface="Work Sans Light"/>
+              </a:rPr>
+              <a:t>Aporte a Luna de Cristal</a:t>
+            </a:r>
+          </a:p>
+          <a:p>
+            <a:pPr indent="-228600" lvl="0" marL="274320" marR="0" rtl="0" algn="l">
+              <a:lnSpc>
+                <a:spcPct val="100000"/>
+              </a:lnSpc>
+              <a:spcBef>
+                <a:spcPts val="0"/>
+              </a:spcBef>
+              <a:spcAft>
+                <a:spcPts val="500"/>
+              </a:spcAft>
+              <a:buClr>
+                <a:srgbClr val="39A935"/>
+              </a:buClr>
+              <a:buSzPct val="90000"/>
+              <a:buFont typeface="Arial"/>
+              <a:buChar char="•"/>
+            </a:pPr>
+            <a:r>
+              <a:rPr lang="es-CO" sz="1500">
+                <a:solidFill>
+                  <a:srgbClr val="262626"/>
+                </a:solidFill>
+                <a:latin typeface="Work Sans Light"/>
+                <a:ea typeface="Work Sans Light"/>
+                <a:cs typeface="Work Sans Light"/>
+                <a:sym typeface="Work Sans Light"/>
+              </a:rPr>
+              <a:t>Es el referente más cercano: mismo sector (comercio minorista de ropa y moda) y su disposición a usar tecnología.</a:t>
+            </a:r>
+          </a:p>
+          <a:p>
+            <a:pPr indent="-228600" lvl="0" marL="274320" marR="0" rtl="0" algn="l">
+              <a:lnSpc>
+                <a:spcPct val="100000"/>
+              </a:lnSpc>
+              <a:spcBef>
+                <a:spcPts val="0"/>
+              </a:spcBef>
+              <a:spcAft>
+                <a:spcPts val="500"/>
+              </a:spcAft>
+              <a:buClr>
+                <a:srgbClr val="39A935"/>
+              </a:buClr>
+              <a:buSzPct val="90000"/>
+              <a:buFont typeface="Arial"/>
+              <a:buChar char="•"/>
+            </a:pPr>
+            <a:r>
+              <a:rPr lang="es-CO" sz="1500">
+                <a:solidFill>
+                  <a:srgbClr val="262626"/>
+                </a:solidFill>
+                <a:latin typeface="Work Sans Light"/>
+                <a:ea typeface="Work Sans Light"/>
+                <a:cs typeface="Work Sans Light"/>
+                <a:sym typeface="Work Sans Light"/>
+              </a:rPr>
+              <a:t>Antes de implementar la solución hay que levantar información directa del negocio y de sus clientes.</a:t>
+            </a:r>
+          </a:p>
+          <a:p>
+            <a:pPr indent="-228600" lvl="0" marL="274320" marR="0" rtl="0" algn="l">
+              <a:lnSpc>
+                <a:spcPct val="100000"/>
+              </a:lnSpc>
+              <a:spcBef>
+                <a:spcPts val="0"/>
+              </a:spcBef>
+              <a:spcAft>
+                <a:spcPts val="0"/>
+              </a:spcAft>
+              <a:buClr>
+                <a:srgbClr val="39A935"/>
+              </a:buClr>
+              <a:buSzPct val="90000"/>
+              <a:buFont typeface="Arial"/>
+              <a:buChar char="•"/>
+            </a:pPr>
+            <a:r>
+              <a:rPr lang="es-CO" sz="1500">
+                <a:solidFill>
+                  <a:srgbClr val="262626"/>
+                </a:solidFill>
+                <a:latin typeface="Work Sans Light"/>
+                <a:ea typeface="Work Sans Light"/>
+                <a:cs typeface="Work Sans Light"/>
+                <a:sym typeface="Work Sans Light"/>
+              </a:rPr>
+              <a:t>El portafolio digital debe ser sencillo, visual e integrarse con ventas, inventario y redes.</a:t>
+            </a:r>
+          </a:p>
+        </p:txBody>
+      </p:sp>
+    </p:spTree>
+  </p:cSld>
+  <p:clrMapOvr>
+    <a:masterClrMapping/>
+  </p:clrMapOvr>
+</p:sld>
+</file>
+
+<file path=ppt/slides/slide32.xml><?xml version="1.0" encoding="utf-8"?>
+<p:sld xmlns:a="http://schemas.openxmlformats.org/drawingml/2006/main" xmlns:r="http://schemas.openxmlformats.org/officeDocument/2006/relationships" xmlns:p="http://schemas.openxmlformats.org/presentationml/2006/main">
+  <p:cSld>
+    <p:bg>
+      <p:bgPr>
+        <a:blipFill>
+          <a:blip r:embed="rId3">
+            <a:alphaModFix/>
+          </a:blip>
+          <a:stretch>
+            <a:fillRect/>
+          </a:stretch>
+        </a:blipFill>
+      </p:bgPr>
+    </p:bg>
+    <p:spTree>
+      <p:nvGrpSpPr>
+        <p:cNvPr id="1" name=""/>
+        <p:cNvGrpSpPr/>
+        <p:nvPr/>
+      </p:nvGrpSpPr>
+      <p:grpSpPr>
+        <a:xfrm>
+          <a:off x="0" y="0"/>
+          <a:ext cx="0" cy="0"/>
+          <a:chOff x="0" y="0"/>
+          <a:chExt cx="0" cy="0"/>
+        </a:xfrm>
+      </p:grpSpPr>
+      <p:sp>
+        <p:nvSpPr>
+          <p:cNvPr id="158" name="encabezado"/>
+          <p:cNvSpPr txBox="1"/>
+          <p:nvPr/>
+        </p:nvSpPr>
+        <p:spPr>
+          <a:xfrm>
+            <a:off x="694944" y="868680"/>
+            <a:ext cx="10789920" cy="822960"/>
+          </a:xfrm>
+          <a:prstGeom prst="rect">
+            <a:avLst/>
+          </a:prstGeom>
+          <a:noFill/>
+          <a:ln>
+            <a:noFill/>
+          </a:ln>
+        </p:spPr>
+        <p:txBody>
+          <a:bodyPr anchorCtr="0" anchor="t" bIns="45700" lIns="91425" spcFirstLastPara="1" rIns="91425" wrap="square" tIns="45700">
+            <a:noAutofit/>
+          </a:bodyPr>
+          <a:lstStyle/>
+          <a:p>
+            <a:pPr indent="0" lvl="0" marL="0" marR="0" rtl="0" algn="l">
+              <a:lnSpc>
+                <a:spcPct val="95000"/>
+              </a:lnSpc>
+              <a:spcBef>
+                <a:spcPts val="0"/>
+              </a:spcBef>
+              <a:spcAft>
+                <a:spcPts val="0"/>
+              </a:spcAft>
+              <a:buNone/>
+            </a:pPr>
+            <a:r>
+              <a:rPr b="1" lang="es-CO" sz="3200">
+                <a:solidFill>
+                  <a:srgbClr val="4D4D4C"/>
+                </a:solidFill>
+                <a:latin typeface="Work Sans"/>
+                <a:ea typeface="Work Sans"/>
+                <a:cs typeface="Work Sans"/>
+                <a:sym typeface="Work Sans"/>
+              </a:rPr>
+              <a:t>Marco histórico</a:t>
+            </a:r>
+          </a:p>
+        </p:txBody>
+      </p:sp>
+      <p:sp>
+        <p:nvSpPr>
+          <p:cNvPr id="159" name="cuerpo"/>
+          <p:cNvSpPr txBox="1"/>
+          <p:nvPr/>
+        </p:nvSpPr>
+        <p:spPr>
+          <a:xfrm>
+            <a:off x="694944" y="1874520"/>
+            <a:ext cx="6309360" cy="4297680"/>
+          </a:xfrm>
+          <a:prstGeom prst="rect">
+            <a:avLst/>
+          </a:prstGeom>
+          <a:noFill/>
+          <a:ln>
+            <a:noFill/>
+          </a:ln>
+        </p:spPr>
+        <p:txBody>
+          <a:bodyPr anchorCtr="0" anchor="t" bIns="45700" lIns="91425" spcFirstLastPara="1" rIns="91425" wrap="square" tIns="45700">
+            <a:noAutofit/>
+          </a:bodyPr>
+          <a:lstStyle/>
+          <a:p>
+            <a:pPr indent="-228600" lvl="0" marL="274320" marR="0" rtl="0" algn="l">
+              <a:lnSpc>
+                <a:spcPct val="100000"/>
+              </a:lnSpc>
+              <a:spcBef>
+                <a:spcPts val="0"/>
+              </a:spcBef>
+              <a:spcAft>
+                <a:spcPts val="500"/>
+              </a:spcAft>
+              <a:buClr>
+                <a:srgbClr val="39A935"/>
+              </a:buClr>
+              <a:buSzPct val="90000"/>
+              <a:buFont typeface="Arial"/>
+              <a:buChar char="•"/>
+            </a:pPr>
+            <a:r>
+              <a:rPr lang="es-CO" sz="1500">
+                <a:solidFill>
+                  <a:srgbClr val="262626"/>
+                </a:solidFill>
+                <a:latin typeface="Work Sans Light"/>
+                <a:ea typeface="Work Sans Light"/>
+                <a:cs typeface="Work Sans Light"/>
+                <a:sym typeface="Work Sans Light"/>
+              </a:rPr>
+              <a:t>El comercio de ropa y accesorios ha pasado de las tiendas físicas tradicionales a modelos apoyados en canales digitales, proceso que se aceleró en los últimos años e impulsa a las microempresas a modernizar su gestión y exhibición (Carrera Mora &amp; González Rosas, 2022).</a:t>
+            </a:r>
+          </a:p>
+          <a:p>
+            <a:pPr indent="-228600" lvl="0" marL="274320" marR="0" rtl="0" algn="l">
+              <a:lnSpc>
+                <a:spcPct val="100000"/>
+              </a:lnSpc>
+              <a:spcBef>
+                <a:spcPts val="0"/>
+              </a:spcBef>
+              <a:spcAft>
+                <a:spcPts val="0"/>
+              </a:spcAft>
+              <a:buClr>
+                <a:srgbClr val="39A935"/>
+              </a:buClr>
+              <a:buSzPct val="90000"/>
+              <a:buFont typeface="Arial"/>
+              <a:buChar char="•"/>
+            </a:pPr>
+            <a:r>
+              <a:rPr lang="es-CO" sz="1500">
+                <a:solidFill>
+                  <a:srgbClr val="262626"/>
+                </a:solidFill>
+                <a:latin typeface="Work Sans Light"/>
+                <a:ea typeface="Work Sans Light"/>
+                <a:cs typeface="Work Sans Light"/>
+                <a:sym typeface="Work Sans Light"/>
+              </a:rPr>
+              <a:t>Luna de Cristal fue fundada en 2026 en Yopal, nacida del deseo de independencia financiera y la pasión por el comercio textil femenino; hoy supera su fase de introducción con un flujo de caja estable (Colsubsidio, 2023).</a:t>
+            </a:r>
+          </a:p>
+        </p:txBody>
+      </p:sp>
+      <p:sp>
+        <p:nvSpPr>
+          <p:cNvPr id="300" name="recuadro"/>
+          <p:cNvSpPr/>
+          <p:nvPr/>
+        </p:nvSpPr>
+        <p:spPr>
+          <a:xfrm>
+            <a:off x="7269480" y="1874520"/>
+            <a:ext cx="4206240" cy="4297680"/>
+          </a:xfrm>
+          <a:prstGeom prst="roundRect">
+            <a:avLst>
+              <a:gd name="adj" fmla="val 6000"/>
+            </a:avLst>
+          </a:prstGeom>
+          <a:solidFill>
+            <a:srgbClr val="EAF5E4"/>
+          </a:solidFill>
+          <a:ln w="19050">
+            <a:solidFill>
+              <a:srgbClr val="39A935"/>
+            </a:solidFill>
+          </a:ln>
+        </p:spPr>
+        <p:txBody>
+          <a:bodyPr wrap="square" lIns="182880" tIns="146304" rIns="182880" bIns="146304" anchor="t">
+            <a:noAutofit/>
+          </a:bodyPr>
+          <a:lstStyle/>
+          <a:p>
+            <a:pPr indent="0" lvl="0" marL="0" marR="0" rtl="0" algn="l">
+              <a:lnSpc>
+                <a:spcPct val="100000"/>
+              </a:lnSpc>
+              <a:spcBef>
+                <a:spcPts val="0"/>
+              </a:spcBef>
+              <a:spcAft>
+                <a:spcPts val="600"/>
+              </a:spcAft>
+              <a:buNone/>
+            </a:pPr>
+            <a:r>
+              <a:rPr lang="es-CO" sz="1700" b="1">
+                <a:solidFill>
+                  <a:srgbClr val="1F6B2E"/>
+                </a:solidFill>
+                <a:latin typeface="Work Sans Light"/>
+                <a:ea typeface="Work Sans Light"/>
+                <a:cs typeface="Work Sans Light"/>
+                <a:sym typeface="Work Sans Light"/>
+              </a:rPr>
+              <a:t>Evolución</a:t>
+            </a:r>
+          </a:p>
+          <a:p>
+            <a:pPr indent="-228600" lvl="0" marL="274320" marR="0" rtl="0" algn="l">
+              <a:lnSpc>
+                <a:spcPct val="100000"/>
+              </a:lnSpc>
+              <a:spcBef>
+                <a:spcPts val="0"/>
+              </a:spcBef>
+              <a:spcAft>
+                <a:spcPts val="400"/>
+              </a:spcAft>
+              <a:buClr>
+                <a:srgbClr val="39A935"/>
+              </a:buClr>
+              <a:buSzPct val="90000"/>
+              <a:buFont typeface="Arial"/>
+              <a:buChar char="•"/>
+            </a:pPr>
+            <a:r>
+              <a:rPr lang="es-CO" sz="1500">
+                <a:solidFill>
+                  <a:srgbClr val="262626"/>
+                </a:solidFill>
+                <a:latin typeface="Work Sans Light"/>
+                <a:ea typeface="Work Sans Light"/>
+                <a:cs typeface="Work Sans Light"/>
+                <a:sym typeface="Work Sans Light"/>
+              </a:rPr>
+              <a:t>Tiendas físicas tradicionales</a:t>
+            </a:r>
+          </a:p>
+          <a:p>
+            <a:pPr indent="-228600" lvl="0" marL="274320" marR="0" rtl="0" algn="l">
+              <a:lnSpc>
+                <a:spcPct val="100000"/>
+              </a:lnSpc>
+              <a:spcBef>
+                <a:spcPts val="0"/>
+              </a:spcBef>
+              <a:spcAft>
+                <a:spcPts val="400"/>
+              </a:spcAft>
+              <a:buClr>
+                <a:srgbClr val="39A935"/>
+              </a:buClr>
+              <a:buSzPct val="90000"/>
+              <a:buFont typeface="Arial"/>
+              <a:buChar char="•"/>
+            </a:pPr>
+            <a:r>
+              <a:rPr lang="es-CO" sz="1500">
+                <a:solidFill>
+                  <a:srgbClr val="262626"/>
+                </a:solidFill>
+                <a:latin typeface="Work Sans Light"/>
+                <a:ea typeface="Work Sans Light"/>
+                <a:cs typeface="Work Sans Light"/>
+                <a:sym typeface="Work Sans Light"/>
+              </a:rPr>
+              <a:t>Comercio apoyado en canales digitales y redes sociales</a:t>
+            </a:r>
+          </a:p>
+          <a:p>
+            <a:pPr indent="-228600" lvl="0" marL="274320" marR="0" rtl="0" algn="l">
+              <a:lnSpc>
+                <a:spcPct val="100000"/>
+              </a:lnSpc>
+              <a:spcBef>
+                <a:spcPts val="0"/>
+              </a:spcBef>
+              <a:spcAft>
+                <a:spcPts val="400"/>
+              </a:spcAft>
+              <a:buClr>
+                <a:srgbClr val="39A935"/>
+              </a:buClr>
+              <a:buSzPct val="90000"/>
+              <a:buFont typeface="Arial"/>
+              <a:buChar char="•"/>
+            </a:pPr>
+            <a:r>
+              <a:rPr lang="es-CO" sz="1500">
+                <a:solidFill>
+                  <a:srgbClr val="262626"/>
+                </a:solidFill>
+                <a:latin typeface="Work Sans Light"/>
+                <a:ea typeface="Work Sans Light"/>
+                <a:cs typeface="Work Sans Light"/>
+                <a:sym typeface="Work Sans Light"/>
+              </a:rPr>
+              <a:t>2026: nace Luna de Cristal, con procesos manuales</a:t>
+            </a:r>
+          </a:p>
+          <a:p>
+            <a:pPr indent="-228600" lvl="0" marL="274320" marR="0" rtl="0" algn="l">
+              <a:lnSpc>
+                <a:spcPct val="100000"/>
+              </a:lnSpc>
+              <a:spcBef>
+                <a:spcPts val="0"/>
+              </a:spcBef>
+              <a:spcAft>
+                <a:spcPts val="0"/>
+              </a:spcAft>
+              <a:buClr>
+                <a:srgbClr val="39A935"/>
+              </a:buClr>
+              <a:buSzPct val="90000"/>
+              <a:buFont typeface="Arial"/>
+              <a:buChar char="•"/>
+            </a:pPr>
+            <a:r>
+              <a:rPr lang="es-CO" sz="1500">
+                <a:solidFill>
+                  <a:srgbClr val="262626"/>
+                </a:solidFill>
+                <a:latin typeface="Work Sans Light"/>
+                <a:ea typeface="Work Sans Light"/>
+                <a:cs typeface="Work Sans Light"/>
+                <a:sym typeface="Work Sans Light"/>
+              </a:rPr>
+              <a:t>Siguiente paso: portafolio digital</a:t>
+            </a:r>
+          </a:p>
+        </p:txBody>
+      </p:sp>
+    </p:spTree>
+  </p:cSld>
+  <p:clrMapOvr>
+    <a:masterClrMapping/>
+  </p:clrMapOvr>
+</p:sld>
+</file>
+
+<file path=ppt/slides/slide33.xml><?xml version="1.0" encoding="utf-8"?>
+<p:sld xmlns:a="http://schemas.openxmlformats.org/drawingml/2006/main" xmlns:r="http://schemas.openxmlformats.org/officeDocument/2006/relationships" xmlns:p="http://schemas.openxmlformats.org/presentationml/2006/main">
+  <p:cSld>
+    <p:bg>
+      <p:bgPr>
+        <a:blipFill>
+          <a:blip r:embed="rId3">
+            <a:alphaModFix/>
+          </a:blip>
+          <a:stretch>
+            <a:fillRect/>
+          </a:stretch>
+        </a:blipFill>
+      </p:bgPr>
+    </p:bg>
+    <p:spTree>
+      <p:nvGrpSpPr>
+        <p:cNvPr id="1" name=""/>
+        <p:cNvGrpSpPr/>
+        <p:nvPr/>
+      </p:nvGrpSpPr>
+      <p:grpSpPr>
+        <a:xfrm>
+          <a:off x="0" y="0"/>
+          <a:ext cx="0" cy="0"/>
+          <a:chOff x="0" y="0"/>
+          <a:chExt cx="0" cy="0"/>
+        </a:xfrm>
+      </p:grpSpPr>
+      <p:sp>
+        <p:nvSpPr>
+          <p:cNvPr id="158" name="encabezado"/>
+          <p:cNvSpPr txBox="1"/>
+          <p:nvPr/>
+        </p:nvSpPr>
+        <p:spPr>
+          <a:xfrm>
+            <a:off x="694944" y="868680"/>
+            <a:ext cx="10789920" cy="822960"/>
+          </a:xfrm>
+          <a:prstGeom prst="rect">
+            <a:avLst/>
+          </a:prstGeom>
+          <a:noFill/>
+          <a:ln>
+            <a:noFill/>
+          </a:ln>
+        </p:spPr>
+        <p:txBody>
+          <a:bodyPr anchorCtr="0" anchor="t" bIns="45700" lIns="91425" spcFirstLastPara="1" rIns="91425" wrap="square" tIns="45700">
+            <a:noAutofit/>
+          </a:bodyPr>
+          <a:lstStyle/>
+          <a:p>
+            <a:pPr indent="0" lvl="0" marL="0" marR="0" rtl="0" algn="l">
+              <a:lnSpc>
+                <a:spcPct val="95000"/>
+              </a:lnSpc>
+              <a:spcBef>
+                <a:spcPts val="0"/>
+              </a:spcBef>
+              <a:spcAft>
+                <a:spcPts val="0"/>
+              </a:spcAft>
+              <a:buNone/>
+            </a:pPr>
+            <a:r>
+              <a:rPr b="1" lang="es-CO" sz="3200">
+                <a:solidFill>
+                  <a:srgbClr val="4D4D4C"/>
+                </a:solidFill>
+                <a:latin typeface="Work Sans"/>
+                <a:ea typeface="Work Sans"/>
+                <a:cs typeface="Work Sans"/>
+                <a:sym typeface="Work Sans"/>
+              </a:rPr>
+              <a:t>Marco institucional</a:t>
+            </a:r>
+          </a:p>
+        </p:txBody>
+      </p:sp>
+      <p:sp>
+        <p:nvSpPr>
+          <p:cNvPr id="159" name="cuerpo"/>
+          <p:cNvSpPr txBox="1"/>
+          <p:nvPr/>
+        </p:nvSpPr>
+        <p:spPr>
+          <a:xfrm>
+            <a:off x="694944" y="1874520"/>
+            <a:ext cx="6309360" cy="4297680"/>
+          </a:xfrm>
+          <a:prstGeom prst="rect">
+            <a:avLst/>
+          </a:prstGeom>
+          <a:noFill/>
+          <a:ln>
+            <a:noFill/>
+          </a:ln>
+        </p:spPr>
+        <p:txBody>
+          <a:bodyPr anchorCtr="0" anchor="t" bIns="45700" lIns="91425" spcFirstLastPara="1" rIns="91425" wrap="square" tIns="45700">
+            <a:noAutofit/>
+          </a:bodyPr>
+          <a:lstStyle/>
+          <a:p>
+            <a:pPr indent="-228600" lvl="0" marL="274320" marR="0" rtl="0" algn="l">
+              <a:lnSpc>
+                <a:spcPct val="100000"/>
+              </a:lnSpc>
+              <a:spcBef>
+                <a:spcPts val="0"/>
+              </a:spcBef>
+              <a:spcAft>
+                <a:spcPts val="400"/>
+              </a:spcAft>
+              <a:buClr>
+                <a:srgbClr val="39A935"/>
+              </a:buClr>
+              <a:buSzPct val="90000"/>
+              <a:buFont typeface="Arial"/>
+              <a:buChar char="•"/>
+            </a:pPr>
+            <a:r>
+              <a:rPr lang="es-CO" sz="1500" b="1">
+                <a:solidFill>
+                  <a:srgbClr val="262626"/>
+                </a:solidFill>
+                <a:latin typeface="Work Sans Light"/>
+                <a:ea typeface="Work Sans Light"/>
+                <a:cs typeface="Work Sans Light"/>
+                <a:sym typeface="Work Sans Light"/>
+              </a:rPr>
+              <a:t>SENA: </a:t>
+            </a:r>
+            <a:r>
+              <a:rPr lang="es-CO" sz="1500">
+                <a:solidFill>
+                  <a:srgbClr val="262626"/>
+                </a:solidFill>
+                <a:latin typeface="Work Sans Light"/>
+                <a:ea typeface="Work Sans Light"/>
+                <a:cs typeface="Work Sans Light"/>
+                <a:sym typeface="Work Sans Light"/>
+              </a:rPr>
+              <a:t>el proyecto se desarrolla en el programa Tecnólogo en Gestión del Desarrollo Administrativo e Innovación, que brinda acompañamiento técnico y metodológico.</a:t>
+            </a:r>
+          </a:p>
+          <a:p>
+            <a:pPr indent="-228600" lvl="0" marL="274320" marR="0" rtl="0" algn="l">
+              <a:lnSpc>
+                <a:spcPct val="100000"/>
+              </a:lnSpc>
+              <a:spcBef>
+                <a:spcPts val="0"/>
+              </a:spcBef>
+              <a:spcAft>
+                <a:spcPts val="400"/>
+              </a:spcAft>
+              <a:buClr>
+                <a:srgbClr val="39A935"/>
+              </a:buClr>
+              <a:buSzPct val="90000"/>
+              <a:buFont typeface="Arial"/>
+              <a:buChar char="•"/>
+            </a:pPr>
+            <a:r>
+              <a:rPr lang="es-CO" sz="1500" b="1">
+                <a:solidFill>
+                  <a:srgbClr val="262626"/>
+                </a:solidFill>
+                <a:latin typeface="Work Sans Light"/>
+                <a:ea typeface="Work Sans Light"/>
+                <a:cs typeface="Work Sans Light"/>
+                <a:sym typeface="Work Sans Light"/>
+              </a:rPr>
+              <a:t>Empresa beneficiaria: </a:t>
+            </a:r>
+            <a:r>
+              <a:rPr lang="es-CO" sz="1500">
+                <a:solidFill>
+                  <a:srgbClr val="262626"/>
+                </a:solidFill>
+                <a:latin typeface="Work Sans Light"/>
+                <a:ea typeface="Work Sans Light"/>
+                <a:cs typeface="Work Sans Light"/>
+                <a:sym typeface="Work Sans Light"/>
+              </a:rPr>
+              <a:t>Luna de Cristal, microempresa constituida como persona natural, comercio al por menor de ropa, perfumería y accesorios (CIIU 4771-4773).</a:t>
+            </a:r>
+          </a:p>
+          <a:p>
+            <a:pPr indent="-228600" lvl="0" marL="274320" marR="0" rtl="0" algn="l">
+              <a:lnSpc>
+                <a:spcPct val="100000"/>
+              </a:lnSpc>
+              <a:spcBef>
+                <a:spcPts val="0"/>
+              </a:spcBef>
+              <a:spcAft>
+                <a:spcPts val="0"/>
+              </a:spcAft>
+              <a:buClr>
+                <a:srgbClr val="39A935"/>
+              </a:buClr>
+              <a:buSzPct val="90000"/>
+              <a:buFont typeface="Arial"/>
+              <a:buChar char="•"/>
+            </a:pPr>
+            <a:r>
+              <a:rPr lang="es-CO" sz="1500" b="1">
+                <a:solidFill>
+                  <a:srgbClr val="262626"/>
+                </a:solidFill>
+                <a:latin typeface="Work Sans Light"/>
+                <a:ea typeface="Work Sans Light"/>
+                <a:cs typeface="Work Sans Light"/>
+                <a:sym typeface="Work Sans Light"/>
+              </a:rPr>
+              <a:t>Estructura: </a:t>
+            </a:r>
+            <a:r>
+              <a:rPr lang="es-CO" sz="1500">
+                <a:solidFill>
+                  <a:srgbClr val="262626"/>
+                </a:solidFill>
+                <a:latin typeface="Work Sans Light"/>
+                <a:ea typeface="Work Sans Light"/>
+                <a:cs typeface="Work Sans Light"/>
+                <a:sym typeface="Work Sans Light"/>
+              </a:rPr>
+              <a:t>horizontal y familiar: Dirección General, canal de ventas físico, canal de ventas digital y domicilios.</a:t>
+            </a:r>
+          </a:p>
+        </p:txBody>
+      </p:sp>
+      <p:sp>
+        <p:nvSpPr>
+          <p:cNvPr id="300" name="recuadro"/>
+          <p:cNvSpPr/>
+          <p:nvPr/>
+        </p:nvSpPr>
+        <p:spPr>
+          <a:xfrm>
+            <a:off x="7269480" y="1874520"/>
+            <a:ext cx="4206240" cy="4297680"/>
+          </a:xfrm>
+          <a:prstGeom prst="roundRect">
+            <a:avLst>
+              <a:gd name="adj" fmla="val 6000"/>
+            </a:avLst>
+          </a:prstGeom>
+          <a:solidFill>
+            <a:srgbClr val="EAF5E4"/>
+          </a:solidFill>
+          <a:ln w="19050">
+            <a:solidFill>
+              <a:srgbClr val="39A935"/>
+            </a:solidFill>
+          </a:ln>
+        </p:spPr>
+        <p:txBody>
+          <a:bodyPr wrap="square" lIns="182880" tIns="146304" rIns="182880" bIns="146304" anchor="t">
+            <a:noAutofit/>
+          </a:bodyPr>
+          <a:lstStyle/>
+          <a:p>
+            <a:pPr indent="0" lvl="0" marL="0" marR="0" rtl="0" algn="l">
+              <a:lnSpc>
+                <a:spcPct val="100000"/>
+              </a:lnSpc>
+              <a:spcBef>
+                <a:spcPts val="0"/>
+              </a:spcBef>
+              <a:spcAft>
+                <a:spcPts val="600"/>
+              </a:spcAft>
+              <a:buNone/>
+            </a:pPr>
+            <a:r>
+              <a:rPr lang="es-CO" sz="1700" b="1">
+                <a:solidFill>
+                  <a:srgbClr val="1F6B2E"/>
+                </a:solidFill>
+                <a:latin typeface="Work Sans Light"/>
+                <a:ea typeface="Work Sans Light"/>
+                <a:cs typeface="Work Sans Light"/>
+                <a:sym typeface="Work Sans Light"/>
+              </a:rPr>
+              <a:t>Filosofía de la empresa</a:t>
+            </a:r>
+          </a:p>
+          <a:p>
+            <a:pPr indent="-228600" lvl="0" marL="274320" marR="0" rtl="0" algn="l">
+              <a:lnSpc>
+                <a:spcPct val="100000"/>
+              </a:lnSpc>
+              <a:spcBef>
+                <a:spcPts val="0"/>
+              </a:spcBef>
+              <a:spcAft>
+                <a:spcPts val="400"/>
+              </a:spcAft>
+              <a:buClr>
+                <a:srgbClr val="39A935"/>
+              </a:buClr>
+              <a:buSzPct val="90000"/>
+              <a:buFont typeface="Arial"/>
+              <a:buChar char="•"/>
+            </a:pPr>
+            <a:r>
+              <a:rPr lang="es-CO" sz="1500" b="1">
+                <a:solidFill>
+                  <a:srgbClr val="262626"/>
+                </a:solidFill>
+                <a:latin typeface="Work Sans Light"/>
+                <a:ea typeface="Work Sans Light"/>
+                <a:cs typeface="Work Sans Light"/>
+                <a:sym typeface="Work Sans Light"/>
+              </a:rPr>
+              <a:t>Misión: </a:t>
+            </a:r>
+            <a:r>
+              <a:rPr lang="es-CO" sz="1500">
+                <a:solidFill>
+                  <a:srgbClr val="262626"/>
+                </a:solidFill>
+                <a:latin typeface="Work Sans Light"/>
+                <a:ea typeface="Work Sans Light"/>
+                <a:cs typeface="Work Sans Light"/>
+                <a:sym typeface="Work Sans Light"/>
+              </a:rPr>
+              <a:t>proveer a las mujeres de Yopal prendas, fragancias y accesorios en tendencia, con precios cómodos y atención cercana.</a:t>
+            </a:r>
+          </a:p>
+          <a:p>
+            <a:pPr indent="-228600" lvl="0" marL="274320" marR="0" rtl="0" algn="l">
+              <a:lnSpc>
+                <a:spcPct val="100000"/>
+              </a:lnSpc>
+              <a:spcBef>
+                <a:spcPts val="0"/>
+              </a:spcBef>
+              <a:spcAft>
+                <a:spcPts val="0"/>
+              </a:spcAft>
+              <a:buClr>
+                <a:srgbClr val="39A935"/>
+              </a:buClr>
+              <a:buSzPct val="90000"/>
+              <a:buFont typeface="Arial"/>
+              <a:buChar char="•"/>
+            </a:pPr>
+            <a:r>
+              <a:rPr lang="es-CO" sz="1500" b="1">
+                <a:solidFill>
+                  <a:srgbClr val="262626"/>
+                </a:solidFill>
+                <a:latin typeface="Work Sans Light"/>
+                <a:ea typeface="Work Sans Light"/>
+                <a:cs typeface="Work Sans Light"/>
+                <a:sym typeface="Work Sans Light"/>
+              </a:rPr>
+              <a:t>Visión 2030: </a:t>
+            </a:r>
+            <a:r>
+              <a:rPr lang="es-CO" sz="1500">
+                <a:solidFill>
+                  <a:srgbClr val="262626"/>
+                </a:solidFill>
+                <a:latin typeface="Work Sans Light"/>
+                <a:ea typeface="Work Sans Light"/>
+                <a:cs typeface="Work Sans Light"/>
+                <a:sym typeface="Work Sans Light"/>
+              </a:rPr>
+              <a:t>ser la tienda de moda femenina líder en Casanare, integrando el canal físico y el digital.</a:t>
+            </a:r>
+          </a:p>
+        </p:txBody>
+      </p:sp>
     </p:spTree>
   </p:cSld>
   <p:clrMapOvr>
@@ -16230,7 +19791,7 @@
                 <a:cs typeface="Work Sans"/>
                 <a:sym typeface="Work Sans"/>
               </a:rPr>
-              <a:t>Antecedentes</a:t>
+              <a:t>Antecedentes y estado actual del conocimiento</a:t>
             </a:r>
           </a:p>
         </p:txBody>
@@ -16256,19 +19817,71 @@
         </p:spPr>
         <p:txBody>
           <a:bodyPr anchorCtr="0" anchor="t" bIns="45700" lIns="91425" spcFirstLastPara="1" rIns="91425" wrap="square" tIns="45700">
-            <a:noAutofit/>
+            <a:normAutofit/>
           </a:bodyPr>
           <a:lstStyle/>
           <a:p>
-            <a:pPr indent="-274320" lvl="0" marL="274320" marR="0" rtl="0" algn="l">
-              <a:lnSpc>
-                <a:spcPct val="110000"/>
-              </a:lnSpc>
-              <a:spcBef>
-                <a:spcPts val="0"/>
-              </a:spcBef>
-              <a:spcAft>
-                <a:spcPts val="600"/>
+            <a:pPr indent="0" lvl="0" marL="0" marR="0" rtl="0" algn="l">
+              <a:lnSpc>
+                <a:spcPct val="100000"/>
+              </a:lnSpc>
+              <a:spcBef>
+                <a:spcPts val="0"/>
+              </a:spcBef>
+              <a:spcAft>
+                <a:spcPts val="700"/>
+              </a:spcAft>
+              <a:buNone/>
+            </a:pPr>
+            <a:r>
+              <a:rPr lang="es-CO" sz="1500">
+                <a:solidFill>
+                  <a:srgbClr val="262626"/>
+                </a:solidFill>
+                <a:latin typeface="Work Sans Light"/>
+                <a:ea typeface="Work Sans Light"/>
+                <a:cs typeface="Work Sans Light"/>
+                <a:sym typeface="Work Sans Light"/>
+              </a:rPr>
+              <a:t>Como antecedentes directos del proyecto se tomaron tres estudios colombianos del sector de la moda y la ropa femenina, por su cercanía con el negocio de Luna de Cristal.</a:t>
+            </a:r>
+          </a:p>
+          <a:p>
+            <a:pPr indent="0" lvl="0" marL="0" marR="0" rtl="0" algn="l">
+              <a:lnSpc>
+                <a:spcPct val="100000"/>
+              </a:lnSpc>
+              <a:spcBef>
+                <a:spcPts val="0"/>
+              </a:spcBef>
+              <a:spcAft>
+                <a:spcPts val="300"/>
+              </a:spcAft>
+              <a:buNone/>
+            </a:pPr>
+            <a:r>
+              <a:rPr lang="es-CO" sz="1500" b="1">
+                <a:solidFill>
+                  <a:srgbClr val="262626"/>
+                </a:solidFill>
+                <a:latin typeface="Work Sans Light"/>
+                <a:ea typeface="Work Sans Light"/>
+                <a:cs typeface="Work Sans Light"/>
+                <a:sym typeface="Work Sans Light"/>
+              </a:rPr>
+              <a:t>Estudios que tomamos:</a:t>
+            </a:r>
+          </a:p>
+          <a:p>
+            <a:pPr indent="-228600" lvl="0" marL="274320" marR="0" rtl="0" algn="l">
+              <a:lnSpc>
+                <a:spcPct val="100000"/>
+              </a:lnSpc>
+              <a:spcBef>
+                <a:spcPts val="0"/>
+              </a:spcBef>
+              <a:spcAft>
+                <a:spcPts val="300"/>
               </a:spcAft>
               <a:buClr>
                 <a:srgbClr val="39A935"/>
@@ -16278,7 +19891,7 @@
               <a:buChar char="•"/>
             </a:pPr>
             <a:r>
-              <a:rPr b="1" lang="es-CO" sz="1800">
+              <a:rPr lang="es-CO" sz="1500" b="1">
                 <a:solidFill>
                   <a:srgbClr val="262626"/>
                 </a:solidFill>
@@ -16287,10 +19900,10 @@
                 <a:cs typeface="Work Sans Light"/>
                 <a:sym typeface="Work Sans Light"/>
               </a:rPr>
-              <a:t>Gallego y Durán (2024): </a:t>
+              <a:t>1. Gallego Arango y Durán Rincón (2024): </a:t>
             </a:r>
             <a:r>
-              <a:rPr lang="es-CO" sz="1800">
+              <a:rPr lang="es-CO" sz="1500">
                 <a:solidFill>
                   <a:srgbClr val="262626"/>
                 </a:solidFill>
@@ -16299,19 +19912,19 @@
                 <a:cs typeface="Work Sans Light"/>
                 <a:sym typeface="Work Sans Light"/>
               </a:rPr>
-              <a:t>el 100 % de las empresas de moda prefiere herramientas visuales, fáciles y compatibles con inventario, QR y redes.</a:t>
+              <a:t>pequeñas empresas de moda y tecnología, Oriente Antioqueño.</a:t>
             </a:r>
           </a:p>
           <a:p>
-            <a:pPr indent="-274320" lvl="0" marL="274320" marR="0" rtl="0" algn="l">
-              <a:lnSpc>
-                <a:spcPct val="110000"/>
-              </a:lnSpc>
-              <a:spcBef>
-                <a:spcPts val="0"/>
-              </a:spcBef>
-              <a:spcAft>
-                <a:spcPts val="600"/>
+            <a:pPr indent="-228600" lvl="0" marL="274320" marR="0" rtl="0" algn="l">
+              <a:lnSpc>
+                <a:spcPct val="100000"/>
+              </a:lnSpc>
+              <a:spcBef>
+                <a:spcPts val="0"/>
+              </a:spcBef>
+              <a:spcAft>
+                <a:spcPts val="300"/>
               </a:spcAft>
               <a:buClr>
                 <a:srgbClr val="39A935"/>
@@ -16321,7 +19934,7 @@
               <a:buChar char="•"/>
             </a:pPr>
             <a:r>
-              <a:rPr b="1" lang="es-CO" sz="1800">
+              <a:rPr lang="es-CO" sz="1500" b="1">
                 <a:solidFill>
                   <a:srgbClr val="262626"/>
                 </a:solidFill>
@@ -16330,10 +19943,10 @@
                 <a:cs typeface="Work Sans Light"/>
                 <a:sym typeface="Work Sans Light"/>
               </a:rPr>
-              <a:t>Fuentes y Mejía (2021): </a:t>
+              <a:t>2. Fuentes y Mejía (2021): </a:t>
             </a:r>
             <a:r>
-              <a:rPr lang="es-CO" sz="1800">
+              <a:rPr lang="es-CO" sz="1500">
                 <a:solidFill>
                   <a:srgbClr val="262626"/>
                 </a:solidFill>
@@ -16342,19 +19955,19 @@
                 <a:cs typeface="Work Sans Light"/>
                 <a:sym typeface="Work Sans Light"/>
               </a:rPr>
-              <a:t>viabilidad de una tienda de ropa deportiva femenina en Sahagún.</a:t>
+              <a:t>tienda de ropa deportiva femenina en Sahagún, Córdoba.</a:t>
             </a:r>
           </a:p>
           <a:p>
-            <a:pPr indent="-274320" lvl="0" marL="274320" marR="0" rtl="0" algn="l">
-              <a:lnSpc>
-                <a:spcPct val="110000"/>
-              </a:lnSpc>
-              <a:spcBef>
-                <a:spcPts val="0"/>
-              </a:spcBef>
-              <a:spcAft>
-                <a:spcPts val="600"/>
+            <a:pPr indent="-228600" lvl="0" marL="274320" marR="0" rtl="0" algn="l">
+              <a:lnSpc>
+                <a:spcPct val="100000"/>
+              </a:lnSpc>
+              <a:spcBef>
+                <a:spcPts val="0"/>
+              </a:spcBef>
+              <a:spcAft>
+                <a:spcPts val="0"/>
               </a:spcAft>
               <a:buClr>
                 <a:srgbClr val="39A935"/>
@@ -16364,7 +19977,7 @@
               <a:buChar char="•"/>
             </a:pPr>
             <a:r>
-              <a:rPr b="1" lang="es-CO" sz="1800">
+              <a:rPr lang="es-CO" sz="1500" b="1">
                 <a:solidFill>
                   <a:srgbClr val="262626"/>
                 </a:solidFill>
@@ -16373,10 +19986,10 @@
                 <a:cs typeface="Work Sans Light"/>
                 <a:sym typeface="Work Sans Light"/>
               </a:rPr>
-              <a:t>Lago Padilla et al. (2024): </a:t>
+              <a:t>3. Lago Padilla et al. (2024): </a:t>
             </a:r>
             <a:r>
-              <a:rPr lang="es-CO" sz="1800">
+              <a:rPr lang="es-CO" sz="1500">
                 <a:solidFill>
                   <a:srgbClr val="262626"/>
                 </a:solidFill>
@@ -16385,7 +19998,7 @@
                 <a:cs typeface="Work Sans Light"/>
                 <a:sym typeface="Work Sans Light"/>
               </a:rPr>
-              <a:t>modelo de negocio CANVAS para una empresa de moda femenina.</a:t>
+              <a:t>Bargui y la moda femenina en Aguachica, Cesar.</a:t>
             </a:r>
           </a:p>
         </p:txBody>

</xml_diff>

<commit_message>
Informe sin notas bajo las tablas; antecedente 3 completo en la presentación
Co-Authored-By: Claude Opus 5.5 <noreply@anthropic.com>
Claude-Session: https://claude.ai/code/session_018bHYprMg3dLh9Z1z1BuPi9
</commit_message>
<xml_diff>
--- a/Luna_de_Cristal_Presentacion_SENA.pptx
+++ b/Luna_de_Cristal_Presentacion_SENA.pptx
@@ -16490,7 +16490,7 @@
                 <a:spcPts val="0"/>
               </a:spcBef>
               <a:spcAft>
-                <a:spcPts val="400"/>
+                <a:spcPts val="250"/>
               </a:spcAft>
               <a:buClr>
                 <a:srgbClr val="39A935"/>
@@ -16500,7 +16500,7 @@
               <a:buChar char="•"/>
             </a:pPr>
             <a:r>
-              <a:rPr lang="es-CO" sz="1500" b="1">
+              <a:rPr lang="es-CO" sz="1400" b="1">
                 <a:solidFill>
                   <a:srgbClr val="262626"/>
                 </a:solidFill>
@@ -16512,7 +16512,7 @@
               <a:t>Enfoque: </a:t>
             </a:r>
             <a:r>
-              <a:rPr lang="es-CO" sz="1500">
+              <a:rPr lang="es-CO" sz="1400">
                 <a:solidFill>
                   <a:srgbClr val="262626"/>
                 </a:solidFill>
@@ -16533,7 +16533,7 @@
                 <a:spcPts val="0"/>
               </a:spcBef>
               <a:spcAft>
-                <a:spcPts val="400"/>
+                <a:spcPts val="250"/>
               </a:spcAft>
               <a:buClr>
                 <a:srgbClr val="39A935"/>
@@ -16543,7 +16543,7 @@
               <a:buChar char="•"/>
             </a:pPr>
             <a:r>
-              <a:rPr lang="es-CO" sz="1500" b="1">
+              <a:rPr lang="es-CO" sz="1400" b="1">
                 <a:solidFill>
                   <a:srgbClr val="262626"/>
                 </a:solidFill>
@@ -16555,7 +16555,7 @@
               <a:t>Tipo y alcance: </a:t>
             </a:r>
             <a:r>
-              <a:rPr lang="es-CO" sz="1500">
+              <a:rPr lang="es-CO" sz="1400">
                 <a:solidFill>
                   <a:srgbClr val="262626"/>
                 </a:solidFill>
@@ -16576,7 +16576,7 @@
                 <a:spcPts val="0"/>
               </a:spcBef>
               <a:spcAft>
-                <a:spcPts val="400"/>
+                <a:spcPts val="250"/>
               </a:spcAft>
               <a:buClr>
                 <a:srgbClr val="39A935"/>
@@ -16586,7 +16586,7 @@
               <a:buChar char="•"/>
             </a:pPr>
             <a:r>
-              <a:rPr lang="es-CO" sz="1500" b="1">
+              <a:rPr lang="es-CO" sz="1400" b="1">
                 <a:solidFill>
                   <a:srgbClr val="262626"/>
                 </a:solidFill>
@@ -16598,7 +16598,7 @@
               <a:t>Diseño: </a:t>
             </a:r>
             <a:r>
-              <a:rPr lang="es-CO" sz="1500">
+              <a:rPr lang="es-CO" sz="1400">
                 <a:solidFill>
                   <a:srgbClr val="262626"/>
                 </a:solidFill>
@@ -16619,7 +16619,7 @@
                 <a:spcPts val="0"/>
               </a:spcBef>
               <a:spcAft>
-                <a:spcPts val="400"/>
+                <a:spcPts val="250"/>
               </a:spcAft>
               <a:buClr>
                 <a:srgbClr val="39A935"/>
@@ -16629,7 +16629,7 @@
               <a:buChar char="•"/>
             </a:pPr>
             <a:r>
-              <a:rPr lang="es-CO" sz="1500" b="1">
+              <a:rPr lang="es-CO" sz="1400" b="1">
                 <a:solidFill>
                   <a:srgbClr val="262626"/>
                 </a:solidFill>
@@ -16638,10 +16638,10 @@
                 <a:cs typeface="Work Sans Light"/>
                 <a:sym typeface="Work Sans Light"/>
               </a:rPr>
-              <a:t>Técnicas: </a:t>
-            </a:r>
-            <a:r>
-              <a:rPr lang="es-CO" sz="1500">
+              <a:t>Población y muestra: </a:t>
+            </a:r>
+            <a:r>
+              <a:rPr lang="es-CO" sz="1400">
                 <a:solidFill>
                   <a:srgbClr val="262626"/>
                 </a:solidFill>
@@ -16650,7 +16650,7 @@
                 <a:cs typeface="Work Sans Light"/>
                 <a:sym typeface="Work Sans Light"/>
               </a:rPr>
-              <a:t>encuestas y revisión de documentación de la empresa.</a:t>
+              <a:t>la demanda femenina del mercado de Bargui en Aguachica, Cesar.</a:t>
             </a:r>
           </a:p>
           <a:p>
@@ -16662,7 +16662,7 @@
                 <a:spcPts val="0"/>
               </a:spcBef>
               <a:spcAft>
-                <a:spcPts val="0"/>
+                <a:spcPts val="250"/>
               </a:spcAft>
               <a:buClr>
                 <a:srgbClr val="39A935"/>
@@ -16672,7 +16672,7 @@
               <a:buChar char="•"/>
             </a:pPr>
             <a:r>
-              <a:rPr lang="es-CO" sz="1500" b="1">
+              <a:rPr lang="es-CO" sz="1400" b="1">
                 <a:solidFill>
                   <a:srgbClr val="262626"/>
                 </a:solidFill>
@@ -16681,10 +16681,10 @@
                 <a:cs typeface="Work Sans Light"/>
                 <a:sym typeface="Work Sans Light"/>
               </a:rPr>
-              <a:t>Resultados: </a:t>
-            </a:r>
-            <a:r>
-              <a:rPr lang="es-CO" sz="1500">
+              <a:t>Técnicas e instrumentos: </a:t>
+            </a:r>
+            <a:r>
+              <a:rPr lang="es-CO" sz="1400">
                 <a:solidFill>
                   <a:srgbClr val="262626"/>
                 </a:solidFill>
@@ -16693,7 +16693,93 @@
                 <a:cs typeface="Work Sans Light"/>
                 <a:sym typeface="Work Sans Light"/>
               </a:rPr>
-              <a:t>la propuesta mostró factibilidad técnica, operativa y financiera, estructurada con el modelo CANVAS.</a:t>
+              <a:t>encuestas y gestión documental de la empresa.</a:t>
+            </a:r>
+          </a:p>
+          <a:p>
+            <a:pPr indent="-228600" lvl="0" marL="274320" marR="0" rtl="0" algn="l">
+              <a:lnSpc>
+                <a:spcPct val="100000"/>
+              </a:lnSpc>
+              <a:spcBef>
+                <a:spcPts val="0"/>
+              </a:spcBef>
+              <a:spcAft>
+                <a:spcPts val="250"/>
+              </a:spcAft>
+              <a:buClr>
+                <a:srgbClr val="39A935"/>
+              </a:buClr>
+              <a:buSzPct val="90000"/>
+              <a:buFont typeface="Arial"/>
+              <a:buChar char="•"/>
+            </a:pPr>
+            <a:r>
+              <a:rPr lang="es-CO" sz="1400" b="1">
+                <a:solidFill>
+                  <a:srgbClr val="262626"/>
+                </a:solidFill>
+                <a:latin typeface="Work Sans Light"/>
+                <a:ea typeface="Work Sans Light"/>
+                <a:cs typeface="Work Sans Light"/>
+                <a:sym typeface="Work Sans Light"/>
+              </a:rPr>
+              <a:t>Análisis de datos: </a:t>
+            </a:r>
+            <a:r>
+              <a:rPr lang="es-CO" sz="1400">
+                <a:solidFill>
+                  <a:srgbClr val="262626"/>
+                </a:solidFill>
+                <a:latin typeface="Work Sans Light"/>
+                <a:ea typeface="Work Sans Light"/>
+                <a:cs typeface="Work Sans Light"/>
+                <a:sym typeface="Work Sans Light"/>
+              </a:rPr>
+              <a:t>cuantitativo y descriptivo; valoró la viabilidad técnica, operativa y financiera con el modelo CANVAS.</a:t>
+            </a:r>
+          </a:p>
+          <a:p>
+            <a:pPr indent="-228600" lvl="0" marL="274320" marR="0" rtl="0" algn="l">
+              <a:lnSpc>
+                <a:spcPct val="100000"/>
+              </a:lnSpc>
+              <a:spcBef>
+                <a:spcPts val="0"/>
+              </a:spcBef>
+              <a:spcAft>
+                <a:spcPts val="0"/>
+              </a:spcAft>
+              <a:buClr>
+                <a:srgbClr val="39A935"/>
+              </a:buClr>
+              <a:buSzPct val="90000"/>
+              <a:buFont typeface="Arial"/>
+              <a:buChar char="•"/>
+            </a:pPr>
+            <a:r>
+              <a:rPr lang="es-CO" sz="1400" b="1">
+                <a:solidFill>
+                  <a:srgbClr val="262626"/>
+                </a:solidFill>
+                <a:latin typeface="Work Sans Light"/>
+                <a:ea typeface="Work Sans Light"/>
+                <a:cs typeface="Work Sans Light"/>
+                <a:sym typeface="Work Sans Light"/>
+              </a:rPr>
+              <a:t>Resultados: </a:t>
+            </a:r>
+            <a:r>
+              <a:rPr lang="es-CO" sz="1400">
+                <a:solidFill>
+                  <a:srgbClr val="262626"/>
+                </a:solidFill>
+                <a:latin typeface="Work Sans Light"/>
+                <a:ea typeface="Work Sans Light"/>
+                <a:cs typeface="Work Sans Light"/>
+                <a:sym typeface="Work Sans Light"/>
+              </a:rPr>
+              <a:t>la propuesta mostró factibilidad técnica, operativa y financiera.</a:t>
             </a:r>
           </a:p>
         </p:txBody>

</xml_diff>

<commit_message>
Informe y presentación: recursos propios, sin introducción, investigación aplicada y competencias del programa
- Recursos y presupuesto: transporte $100.000, equipo de cómputo $3.000.000,
  internet $280.000 (total $3.380.000, recursos propios)
- Se retira la introducción (se redacta al terminar el proyecto)
- Tipo de investigación: aplicada
- Tabla de competencias técnicas del programa 122153 en el marco institucional

Co-Authored-By: Claude Opus 5.5 <noreply@anthropic.com>
Claude-Session: https://claude.ai/code/session_018bHYprMg3dLh9Z1z1BuPi9
</commit_message>
<xml_diff>
--- a/Luna_de_Cristal_Presentacion_SENA.pptx
+++ b/Luna_de_Cristal_Presentacion_SENA.pptx
@@ -10,7 +10,6 @@
   <p:sldIdLst>
     <p:sldId id="256" r:id="rId101"/>
     <p:sldId id="257" r:id="rId102"/>
-    <p:sldId id="258" r:id="rId103"/>
     <p:sldId id="259" r:id="rId104"/>
     <p:sldId id="286" r:id="rId131"/>
     <p:sldId id="285" r:id="rId130"/>
@@ -14890,7 +14889,7 @@
                 <a:cs typeface="Work Sans"/>
                 <a:sym typeface="Work Sans"/>
               </a:rPr>
-              <a:t>Introducción y antecedentes</a:t>
+              <a:t>Antecedentes</a:t>
             </a:r>
           </a:p>
         </p:txBody>
@@ -15031,7 +15030,7 @@
                 <a:cs typeface="Work Sans Light"/>
                 <a:sym typeface="Work Sans Light"/>
               </a:rPr>
-              <a:t>Enfoque mixto, alcance descriptivo: </a:t>
+              <a:t>Investigación aplicada, enfoque mixto y alcance descriptivo: </a:t>
             </a:r>
             <a:r>
               <a:rPr lang="es-CO" sz="1800">
@@ -15043,7 +15042,7 @@
                 <a:cs typeface="Work Sans Light"/>
                 <a:sym typeface="Work Sans Light"/>
               </a:rPr>
-              <a:t>combina observación y entrevista a la propietaria con encuesta a las clientas.</a:t>
+              <a:t>combina observación y entrevista a la propietaria con encuestas a clientes internos, clientes externos y proveedores.</a:t>
             </a:r>
           </a:p>
           <a:p>
@@ -15861,7 +15860,7 @@
                 <a:cs typeface="Work Sans Light"/>
                 <a:sym typeface="Work Sans Light"/>
               </a:rPr>
-              <a:t>talento humano (propietaria, asesor y aprendices SENA), local dotado, inversión propia y tecnología (computador, WhatsApp Business, redes y facturación básica).</a:t>
+              <a:t>recursos propios del equipo: transporte (gasolina) $100.000, equipo de cómputo $3.000.000 y servicio de internet $280.000.</a:t>
             </a:r>
           </a:p>
           <a:p>
@@ -15899,7 +15898,7 @@
                 <a:cs typeface="Work Sans Light"/>
                 <a:sym typeface="Work Sans Light"/>
               </a:rPr>
-              <a:t>busca el menor costo posible para la microempresa.</a:t>
+              <a:t>$3.380.000 COP, financiado con recursos propios.</a:t>
             </a:r>
           </a:p>
           <a:p>
@@ -17856,237 +17855,6 @@
           </a:p>
         </p:txBody>
       </p:sp>
-    </p:spTree>
-  </p:cSld>
-  <p:clrMapOvr>
-    <a:masterClrMapping/>
-  </p:clrMapOvr>
-</p:sld>
-</file>
-
-<file path=ppt/slides/slide3.xml><?xml version="1.0" encoding="utf-8"?>
-<p:sld xmlns:a="http://schemas.openxmlformats.org/drawingml/2006/main" xmlns:r="http://schemas.openxmlformats.org/officeDocument/2006/relationships" xmlns:p="http://schemas.openxmlformats.org/presentationml/2006/main">
-  <p:cSld>
-    <p:bg>
-      <p:bgPr>
-        <a:blipFill>
-          <a:blip r:embed="rId3">
-            <a:alphaModFix/>
-          </a:blip>
-          <a:stretch>
-            <a:fillRect/>
-          </a:stretch>
-        </a:blipFill>
-      </p:bgPr>
-    </p:bg>
-    <p:spTree>
-      <p:nvGrpSpPr>
-        <p:cNvPr id="1" name=""/>
-        <p:cNvGrpSpPr/>
-        <p:nvPr/>
-      </p:nvGrpSpPr>
-      <p:grpSpPr>
-        <a:xfrm>
-          <a:off x="0" y="0"/>
-          <a:ext cx="0" cy="0"/>
-          <a:chOff x="0" y="0"/>
-          <a:chExt cx="0" cy="0"/>
-        </a:xfrm>
-      </p:grpSpPr>
-      <p:sp>
-        <p:nvSpPr>
-          <p:cNvPr id="158" name="encabezado"/>
-          <p:cNvSpPr txBox="1"/>
-          <p:nvPr/>
-        </p:nvSpPr>
-        <p:spPr>
-          <a:xfrm>
-            <a:off x="694944" y="868680"/>
-            <a:ext cx="10789920" cy="822960"/>
-          </a:xfrm>
-          <a:prstGeom prst="rect">
-            <a:avLst/>
-          </a:prstGeom>
-          <a:noFill/>
-          <a:ln>
-            <a:noFill/>
-          </a:ln>
-        </p:spPr>
-        <p:txBody>
-          <a:bodyPr anchorCtr="0" anchor="t" bIns="45700" lIns="91425" spcFirstLastPara="1" rIns="91425" wrap="square" tIns="45700">
-            <a:noAutofit/>
-          </a:bodyPr>
-          <a:lstStyle/>
-          <a:p>
-            <a:pPr indent="0" lvl="0" marL="0" marR="0" rtl="0" algn="l">
-              <a:lnSpc>
-                <a:spcPct val="95000"/>
-              </a:lnSpc>
-              <a:spcBef>
-                <a:spcPts val="0"/>
-              </a:spcBef>
-              <a:spcAft>
-                <a:spcPts val="0"/>
-              </a:spcAft>
-              <a:buNone/>
-            </a:pPr>
-            <a:r>
-              <a:rPr b="1" lang="es-CO" sz="3200">
-                <a:solidFill>
-                  <a:srgbClr val="4D4D4C"/>
-                </a:solidFill>
-                <a:latin typeface="Work Sans"/>
-                <a:ea typeface="Work Sans"/>
-                <a:cs typeface="Work Sans"/>
-                <a:sym typeface="Work Sans"/>
-              </a:rPr>
-              <a:t>Introducción</a:t>
-            </a:r>
-          </a:p>
-        </p:txBody>
-      </p:sp>
-      <p:sp>
-        <p:nvSpPr>
-          <p:cNvPr id="159" name="cuerpo"/>
-          <p:cNvSpPr txBox="1"/>
-          <p:nvPr/>
-        </p:nvSpPr>
-        <p:spPr>
-          <a:xfrm>
-            <a:off x="694944" y="1874520"/>
-            <a:ext cx="6309360" cy="4297680"/>
-          </a:xfrm>
-          <a:prstGeom prst="rect">
-            <a:avLst/>
-          </a:prstGeom>
-          <a:noFill/>
-          <a:ln>
-            <a:noFill/>
-          </a:ln>
-        </p:spPr>
-        <p:txBody>
-          <a:bodyPr anchorCtr="0" anchor="t" bIns="45700" lIns="91425" spcFirstLastPara="1" rIns="91425" wrap="square" tIns="45700">
-            <a:noAutofit/>
-          </a:bodyPr>
-          <a:lstStyle/>
-          <a:p>
-            <a:pPr indent="0" lvl="0" marL="0" marR="0" rtl="0" algn="l">
-              <a:lnSpc>
-                <a:spcPct val="110000"/>
-              </a:lnSpc>
-              <a:spcBef>
-                <a:spcPts val="0"/>
-              </a:spcBef>
-              <a:spcAft>
-                <a:spcPts val="600"/>
-              </a:spcAft>
-              <a:buNone/>
-            </a:pPr>
-            <a:r>
-              <a:rPr lang="es-CO" sz="1800">
-                <a:solidFill>
-                  <a:srgbClr val="262626"/>
-                </a:solidFill>
-                <a:latin typeface="Work Sans Light"/>
-                <a:ea typeface="Work Sans Light"/>
-                <a:cs typeface="Work Sans Light"/>
-                <a:sym typeface="Work Sans Light"/>
-              </a:rPr>
-              <a:t>La transformación digital es hoy una condición de supervivencia para el pequeño comercio.</a:t>
-            </a:r>
-          </a:p>
-          <a:p>
-            <a:pPr indent="0" lvl="0" marL="0" marR="0" rtl="0" algn="l">
-              <a:lnSpc>
-                <a:spcPct val="110000"/>
-              </a:lnSpc>
-              <a:spcBef>
-                <a:spcPts val="0"/>
-              </a:spcBef>
-              <a:spcAft>
-                <a:spcPts val="600"/>
-              </a:spcAft>
-              <a:buNone/>
-            </a:pPr>
-            <a:r>
-              <a:rPr lang="es-CO" sz="1800">
-                <a:solidFill>
-                  <a:srgbClr val="262626"/>
-                </a:solidFill>
-                <a:latin typeface="Work Sans Light"/>
-                <a:ea typeface="Work Sans Light"/>
-                <a:cs typeface="Work Sans Light"/>
-                <a:sym typeface="Work Sans Light"/>
-              </a:rPr>
-              <a:t>Luna de Cristal —tienda de ropa, perfumes y correas en Yopal— administra su inventario, ventas y clientes de forma manual.</a:t>
-            </a:r>
-          </a:p>
-          <a:p>
-            <a:pPr indent="0" lvl="0" marL="0" marR="0" rtl="0" algn="l">
-              <a:lnSpc>
-                <a:spcPct val="110000"/>
-              </a:lnSpc>
-              <a:spcBef>
-                <a:spcPts val="0"/>
-              </a:spcBef>
-              <a:spcAft>
-                <a:spcPts val="600"/>
-              </a:spcAft>
-              <a:buNone/>
-            </a:pPr>
-            <a:r>
-              <a:rPr lang="es-CO" sz="1800">
-                <a:solidFill>
-                  <a:srgbClr val="262626"/>
-                </a:solidFill>
-                <a:latin typeface="Work Sans Light"/>
-                <a:ea typeface="Work Sans Light"/>
-                <a:cs typeface="Work Sans Light"/>
-                <a:sym typeface="Work Sans Light"/>
-              </a:rPr>
-              <a:t>Este anteproyecto propone un portafolio digital para ordenar y modernizar sus procesos administrativos.</a:t>
-            </a:r>
-          </a:p>
-        </p:txBody>
-      </p:sp>
-      <p:pic>
-        <p:nvPicPr>
-          <p:cNvPr id="200" name="imagen"/>
-          <p:cNvPicPr/>
-          <p:nvPr/>
-        </p:nvPicPr>
-        <p:blipFill>
-          <a:blip r:embed="rId5">
-            <a:alphaModFix/>
-          </a:blip>
-          <a:stretch>
-            <a:fillRect/>
-          </a:stretch>
-        </p:blipFill>
-        <p:spPr>
-          <a:xfrm>
-            <a:off x="7269480" y="1920240"/>
-            <a:ext cx="4114800" cy="3090672"/>
-          </a:xfrm>
-          <a:prstGeom prst="roundRect">
-            <a:avLst>
-              <a:gd name="adj" fmla="val 5000"/>
-            </a:avLst>
-          </a:prstGeom>
-          <a:ln w="12700">
-            <a:solidFill>
-              <a:srgbClr val="FFFFFF"/>
-            </a:solidFill>
-          </a:ln>
-          <a:effectLst>
-            <a:outerShdw blurRad="50000" dist="25000" dir="5400000" rotWithShape="0">
-              <a:srgbClr val="000000">
-                <a:alpha val="25000"/>
-              </a:srgbClr>
-            </a:outerShdw>
-          </a:effectLst>
-        </p:spPr>
-      </p:pic>
     </p:spTree>
   </p:cSld>
   <p:clrMapOvr>

</xml_diff>

<commit_message>
Informe y presentación sin rayas; informe renombrado a Reunión
- Rayas (— y –) reemplazadas por paréntesis, comas o dos puntos
- Archivo del informe: Informe_Luna_de_Cristal_Reunión.docx

Co-Authored-By: Claude Opus 5.5 <noreply@anthropic.com>
Claude-Session: https://claude.ai/code/session_018bHYprMg3dLh9Z1z1BuPi9
</commit_message>
<xml_diff>
--- a/Luna_de_Cristal_Presentacion_SENA.pptx
+++ b/Luna_de_Cristal_Presentacion_SENA.pptx
@@ -12236,7 +12236,7 @@
                 <a:cs typeface="Work Sans Light"/>
                 <a:sym typeface="Work Sans Light"/>
               </a:rPr>
-              <a:t>Tecnólogo en Gestión del Desarrollo Administrativo e Innovación — SENA</a:t>
+              <a:t>Tecnólogo en Gestión del Desarrollo Administrativo e Innovación (SENA)</a:t>
             </a:r>
           </a:p>
           <a:p>
@@ -20170,7 +20170,7 @@
                 <a:cs typeface="Work Sans Light"/>
                 <a:sym typeface="Work Sans Light"/>
               </a:rPr>
-              <a:t>fase de planeación —diagnóstico y diseño de la propuesta—, sin implementación definitiva.</a:t>
+              <a:t>fase de planeación (diagnóstico y diseño de la propuesta), sin implementación definitiva.</a:t>
             </a:r>
           </a:p>
           <a:p>

</xml_diff>

<commit_message>
Presentación: viñetas sin rayas
Co-Authored-By: Claude Opus 5.5 <noreply@anthropic.com>
Claude-Session: https://claude.ai/code/session_018bHYprMg3dLh9Z1z1BuPi9
</commit_message>
<xml_diff>
--- a/Luna_de_Cristal_Presentacion_SENA.pptx
+++ b/Luna_de_Cristal_Presentacion_SENA.pptx
@@ -17144,7 +17144,7 @@
               </a:buClr>
               <a:buSzPct val="90000"/>
               <a:buFont typeface="Arial"/>
-              <a:buChar char="–"/>
+              <a:buChar char="•"/>
             </a:pPr>
             <a:r>
               <a:rPr lang="es-CO" sz="1400">
@@ -17175,7 +17175,7 @@
               </a:buClr>
               <a:buSzPct val="90000"/>
               <a:buFont typeface="Arial"/>
-              <a:buChar char="–"/>
+              <a:buChar char="•"/>
             </a:pPr>
             <a:r>
               <a:rPr lang="es-CO" sz="1400">
@@ -17206,7 +17206,7 @@
               </a:buClr>
               <a:buSzPct val="90000"/>
               <a:buFont typeface="Arial"/>
-              <a:buChar char="–"/>
+              <a:buChar char="•"/>
             </a:pPr>
             <a:r>
               <a:rPr lang="es-CO" sz="1400">
@@ -18096,7 +18096,7 @@
               </a:buClr>
               <a:buSzPct val="90000"/>
               <a:buFont typeface="Arial"/>
-              <a:buChar char="–"/>
+              <a:buChar char="•"/>
             </a:pPr>
             <a:r>
               <a:rPr lang="es-CO" sz="1400">
@@ -18127,7 +18127,7 @@
               </a:buClr>
               <a:buSzPct val="90000"/>
               <a:buFont typeface="Arial"/>
-              <a:buChar char="–"/>
+              <a:buChar char="•"/>
             </a:pPr>
             <a:r>
               <a:rPr lang="es-CO" sz="1400">
@@ -18158,7 +18158,7 @@
               </a:buClr>
               <a:buSzPct val="90000"/>
               <a:buFont typeface="Arial"/>
-              <a:buChar char="–"/>
+              <a:buChar char="•"/>
             </a:pPr>
             <a:r>
               <a:rPr lang="es-CO" sz="1400">
@@ -18189,7 +18189,7 @@
               </a:buClr>
               <a:buSzPct val="90000"/>
               <a:buFont typeface="Arial"/>
-              <a:buChar char="–"/>
+              <a:buChar char="•"/>
             </a:pPr>
             <a:r>
               <a:rPr lang="es-CO" sz="1400">
@@ -18220,7 +18220,7 @@
               </a:buClr>
               <a:buSzPct val="90000"/>
               <a:buFont typeface="Arial"/>
-              <a:buChar char="–"/>
+              <a:buChar char="•"/>
             </a:pPr>
             <a:r>
               <a:rPr lang="es-CO" sz="1400">

</xml_diff>